<commit_message>
Update: severity fixes, CORS fix, ObjectId fix, toast UI, PDF reports added
- pothole_analyzer.py: lower severity thresholds & physical size limits for better real-world accuracy
- backend/main.py: fix CORS (explicit origins), steeper RHI deductions
- backend/database.py: fix ObjectId mutation bug in save_detections()
- frontend/src/App.jsx: add toast notifications, fix refresh button behavior
- Add end-semester presentation PDF/PPTX and project report PDF

Co-Authored-By: Claude Sonnet 4.6 <noreply@anthropic.com>
</commit_message>
<xml_diff>
--- a/PavemindAI_Group_Presentation_SAFE.pptx
+++ b/PavemindAI_Group_Presentation_SAFE.pptx
@@ -4,6 +4,9 @@
   <p:sldMasterIdLst>
     <p:sldMasterId id="2147483648" r:id="rId1"/>
   </p:sldMasterIdLst>
+  <p:notesMasterIdLst>
+    <p:notesMasterId r:id="rId12"/>
+  </p:notesMasterIdLst>
   <p:sldIdLst>
     <p:sldId id="256" r:id="rId2"/>
     <p:sldId id="257" r:id="rId3"/>
@@ -16,9 +19,6 @@
     <p:sldId id="264" r:id="rId10"/>
     <p:sldId id="265" r:id="rId11"/>
   </p:sldIdLst>
-  <p:notesMasterIdLst>
-    <p:notesMasterId r:id="rId12"/>
-  </p:notesMasterIdLst>
   <p:sldSz cx="12192000" cy="6858000"/>
   <p:notesSz cx="6858000" cy="12192000"/>
   <p:defaultTextStyle>
@@ -113,6 +113,11 @@
       </a:defRPr>
     </a:lvl9pPr>
   </p:defaultTextStyle>
+  <p:extLst>
+    <p:ext uri="{EFAFB233-063F-42B5-8137-9DF3F51BA10A}">
+      <p15:sldGuideLst xmlns:p15="http://schemas.microsoft.com/office/powerpoint/2012/main"/>
+    </p:ext>
+  </p:extLst>
 </p:presentation>
 </file>
 
@@ -138,234 +143,10 @@
           <a:chExt cx="0" cy="0"/>
         </a:xfrm>
       </p:grpSpPr>
-      <p:sp>
-        <p:nvSpPr>
-          <p:cNvPr id="2" name="Header Placeholder 1"/>
-          <p:cNvSpPr>
-            <a:spLocks noGrp="1"/>
-          </p:cNvSpPr>
-          <p:nvPr>
-            <p:ph type="hdr" sz="quarter"/>
-          </p:nvPr>
-        </p:nvSpPr>
-        <p:spPr>
-          <a:xfrm>
-            <a:off x="0" y="0"/>
-            <a:ext cx="2971800" cy="458788"/>
-          </a:xfrm>
-          <a:prstGeom prst="rect">
-            <a:avLst/>
-          </a:prstGeom>
-        </p:spPr>
-        <p:txBody>
-          <a:bodyPr vert="horz" lIns="91440" tIns="45720" rIns="91440" bIns="45720" rtlCol="0"/>
-          <a:lstStyle>
-            <a:lvl1pPr algn="l">
-              <a:defRPr sz="1200"/>
-            </a:lvl1pPr>
-          </a:lstStyle>
-          <a:p>
-            <a:endParaRPr lang="en-US"/>
-          </a:p>
-        </p:txBody>
-      </p:sp>
-      <p:sp>
-        <p:nvSpPr>
-          <p:cNvPr id="3" name="Date Placeholder 2"/>
-          <p:cNvSpPr>
-            <a:spLocks noGrp="1"/>
-          </p:cNvSpPr>
-          <p:nvPr>
-            <p:ph type="dt" idx="1"/>
-          </p:nvPr>
-        </p:nvSpPr>
-        <p:spPr>
-          <a:xfrm>
-            <a:off x="3884613" y="0"/>
-            <a:ext cx="2971800" cy="458788"/>
-          </a:xfrm>
-          <a:prstGeom prst="rect">
-            <a:avLst/>
-          </a:prstGeom>
-        </p:spPr>
-        <p:txBody>
-          <a:bodyPr vert="horz" lIns="91440" tIns="45720" rIns="91440" bIns="45720" rtlCol="0"/>
-          <a:lstStyle>
-            <a:lvl1pPr algn="r">
-              <a:defRPr sz="1200"/>
-            </a:lvl1pPr>
-          </a:lstStyle>
-          <a:p>
-            <a:fld id="{5282F153-3F37-0F45-9E97-73ACFA13230C}" type="datetimeFigureOut">
-              <a:rPr lang="en-US"/>
-              <a:t>7/23/19</a:t>
-            </a:fld>
-            <a:endParaRPr lang="en-US"/>
-          </a:p>
-        </p:txBody>
-      </p:sp>
-      <p:sp>
-        <p:nvSpPr>
-          <p:cNvPr id="4" name="Slide Image Placeholder 3"/>
-          <p:cNvSpPr>
-            <a:spLocks noGrp="1" noRot="1" noChangeAspect="1"/>
-          </p:cNvSpPr>
-          <p:nvPr>
-            <p:ph type="sldImg" idx="2"/>
-          </p:nvPr>
-        </p:nvSpPr>
-        <p:spPr>
-          <a:xfrm>
-            <a:off x="685800" y="1143000"/>
-            <a:ext cx="5486400" cy="3086100"/>
-          </a:xfrm>
-          <a:prstGeom prst="rect">
-            <a:avLst/>
-          </a:prstGeom>
-          <a:noFill/>
-          <a:ln w="12700">
-            <a:solidFill>
-              <a:prstClr val="black"/>
-            </a:solidFill>
-          </a:ln>
-        </p:spPr>
-        <p:txBody>
-          <a:bodyPr vert="horz" lIns="91440" tIns="45720" rIns="91440" bIns="45720" rtlCol="0" anchor="ctr"/>
-          <a:lstStyle/>
-          <a:p>
-            <a:endParaRPr lang="en-US"/>
-          </a:p>
-        </p:txBody>
-      </p:sp>
-      <p:sp>
-        <p:nvSpPr>
-          <p:cNvPr id="5" name="Notes Placeholder 4"/>
-          <p:cNvSpPr>
-            <a:spLocks noGrp="1"/>
-          </p:cNvSpPr>
-          <p:nvPr>
-            <p:ph type="body" sz="quarter" idx="3"/>
-          </p:nvPr>
-        </p:nvSpPr>
-        <p:spPr>
-          <a:xfrm>
-            <a:off x="685800" y="4400550"/>
-            <a:ext cx="5486400" cy="3600450"/>
-          </a:xfrm>
-          <a:prstGeom prst="rect">
-            <a:avLst/>
-          </a:prstGeom>
-        </p:spPr>
-        <p:txBody>
-          <a:bodyPr vert="horz" lIns="91440" tIns="45720" rIns="91440" bIns="45720" rtlCol="0"/>
-          <a:lstStyle/>
-          <a:p>
-            <a:pPr lvl="0"/>
-            <a:r>
-              <a:rPr lang="en-US"/>
-              <a:t>Click to edit Master text styles</a:t>
-            </a:r>
-          </a:p>
-          <a:p>
-            <a:pPr lvl="1"/>
-            <a:r>
-              <a:rPr lang="en-US"/>
-              <a:t>Second level</a:t>
-            </a:r>
-          </a:p>
-          <a:p>
-            <a:pPr lvl="2"/>
-            <a:r>
-              <a:rPr lang="en-US"/>
-              <a:t>Third level</a:t>
-            </a:r>
-          </a:p>
-          <a:p>
-            <a:pPr lvl="3"/>
-            <a:r>
-              <a:rPr lang="en-US"/>
-              <a:t>Fourth level</a:t>
-            </a:r>
-          </a:p>
-          <a:p>
-            <a:pPr lvl="4"/>
-            <a:r>
-              <a:rPr lang="en-US"/>
-              <a:t>Fifth level</a:t>
-            </a:r>
-          </a:p>
-        </p:txBody>
-      </p:sp>
-      <p:sp>
-        <p:nvSpPr>
-          <p:cNvPr id="6" name="Footer Placeholder 5"/>
-          <p:cNvSpPr>
-            <a:spLocks noGrp="1"/>
-          </p:cNvSpPr>
-          <p:nvPr>
-            <p:ph type="ftr" sz="quarter" idx="4"/>
-          </p:nvPr>
-        </p:nvSpPr>
-        <p:spPr>
-          <a:xfrm>
-            <a:off x="0" y="8685213"/>
-            <a:ext cx="2971800" cy="458787"/>
-          </a:xfrm>
-          <a:prstGeom prst="rect">
-            <a:avLst/>
-          </a:prstGeom>
-        </p:spPr>
-        <p:txBody>
-          <a:bodyPr vert="horz" lIns="91440" tIns="45720" rIns="91440" bIns="45720" rtlCol="0" anchor="b"/>
-          <a:lstStyle>
-            <a:lvl1pPr algn="l">
-              <a:defRPr sz="1200"/>
-            </a:lvl1pPr>
-          </a:lstStyle>
-          <a:p>
-            <a:endParaRPr lang="en-US"/>
-          </a:p>
-        </p:txBody>
-      </p:sp>
-      <p:sp>
-        <p:nvSpPr>
-          <p:cNvPr id="7" name="Slide Number Placeholder 6"/>
-          <p:cNvSpPr>
-            <a:spLocks noGrp="1"/>
-          </p:cNvSpPr>
-          <p:nvPr>
-            <p:ph type="sldNum" sz="quarter" idx="5"/>
-          </p:nvPr>
-        </p:nvSpPr>
-        <p:spPr>
-          <a:xfrm>
-            <a:off x="3884613" y="8685213"/>
-            <a:ext cx="2971800" cy="458787"/>
-          </a:xfrm>
-          <a:prstGeom prst="rect">
-            <a:avLst/>
-          </a:prstGeom>
-        </p:spPr>
-        <p:txBody>
-          <a:bodyPr vert="horz" lIns="91440" tIns="45720" rIns="91440" bIns="45720" rtlCol="0" anchor="b"/>
-          <a:lstStyle>
-            <a:lvl1pPr algn="r">
-              <a:defRPr sz="1200"/>
-            </a:lvl1pPr>
-          </a:lstStyle>
-          <a:p>
-            <a:fld id="{CE5E9CC1-C706-0F49-92D6-E571CC5EEA8F}" type="slidenum">
-              <a:rPr lang="en-US"/>
-              <a:t>‹#›</a:t>
-            </a:fld>
-            <a:endParaRPr lang="en-US"/>
-          </a:p>
-        </p:txBody>
-      </p:sp>
     </p:spTree>
     <p:extLst>
       <p:ext uri="{BB962C8B-B14F-4D97-AF65-F5344CB8AC3E}">
-        <p14:creationId xmlns:p14="http://schemas.microsoft.com/office/powerpoint/2010/main" val="1024086991"/>
+        <p14:creationId xmlns:p14="http://schemas.microsoft.com/office/powerpoint/2010/main" val="2798720445"/>
       </p:ext>
     </p:extLst>
   </p:cSld>
@@ -513,7 +294,6 @@
               <a:rPr lang="en-US" dirty="0"/>
               <a:t>Cover. Introduce team + project title. 15-20 seconds max.</a:t>
             </a:r>
-            <a:endParaRPr lang="en-US" dirty="0"/>
           </a:p>
         </p:txBody>
       </p:sp>
@@ -601,7 +381,6 @@
               <a:rPr lang="en-US" dirty="0"/>
               <a:t>Pause. Invite questions. If asked something technical you don't want to answer publicly, deflect: 'Great question — happy to walk you through it after the session.'</a:t>
             </a:r>
-            <a:endParaRPr lang="en-US" dirty="0"/>
           </a:p>
         </p:txBody>
       </p:sp>
@@ -689,7 +468,6 @@
               <a:rPr lang="en-US" dirty="0"/>
               <a:t>Set up the pain. Reactive, manual, unquantified. Hand off to the solution.</a:t>
             </a:r>
-            <a:endParaRPr lang="en-US" dirty="0"/>
           </a:p>
         </p:txBody>
       </p:sp>
@@ -777,7 +555,6 @@
               <a:rPr lang="en-US" dirty="0"/>
               <a:t>Three pillars. Detect → Grade → Prioritise. Next slides expand each.</a:t>
             </a:r>
-            <a:endParaRPr lang="en-US" dirty="0"/>
           </a:p>
         </p:txBody>
       </p:sp>
@@ -865,7 +642,6 @@
               <a:rPr lang="en-US" dirty="0"/>
               <a:t>Walk left-to-right. Emphasize automation. Don't get pulled into HOW the AI works.</a:t>
             </a:r>
-            <a:endParaRPr lang="en-US" dirty="0"/>
           </a:p>
         </p:txBody>
       </p:sp>
@@ -953,7 +729,6 @@
               <a:rPr lang="en-US" dirty="0"/>
               <a:t>Read the stack briefly. If asked 'why FastAPI' → 'async + auto docs.' Don't over-explain.</a:t>
             </a:r>
-            <a:endParaRPr lang="en-US" dirty="0"/>
           </a:p>
         </p:txBody>
       </p:sp>
@@ -1041,7 +816,6 @@
               <a:rPr lang="en-US" dirty="0"/>
               <a:t>Point to the image. Many potholes in ONE frame — each with cm measurements. Then the 91% accuracy on the right.</a:t>
             </a:r>
-            <a:endParaRPr lang="en-US" dirty="0"/>
           </a:p>
         </p:txBody>
       </p:sp>
@@ -1129,7 +903,6 @@
               <a:rPr lang="en-US" dirty="0"/>
               <a:t>Three tiers. Point to the alert banner. Do NOT get into HOW severity is decided.</a:t>
             </a:r>
-            <a:endParaRPr lang="en-US" dirty="0"/>
           </a:p>
         </p:txBody>
       </p:sp>
@@ -1217,7 +990,6 @@
               <a:rPr lang="en-US" dirty="0"/>
               <a:t>Emphasize: one number = actionable. Cities can rank 500 roads at once. DO NOT reveal the exact formula.</a:t>
             </a:r>
-            <a:endParaRPr lang="en-US" dirty="0"/>
           </a:p>
         </p:txBody>
       </p:sp>
@@ -1305,7 +1077,6 @@
               <a:rPr lang="en-US" dirty="0"/>
               <a:t>Impact slide. Zero hardware cost is the punchline.</a:t>
             </a:r>
-            <a:endParaRPr lang="en-US" dirty="0"/>
           </a:p>
         </p:txBody>
       </p:sp>
@@ -1378,6 +1149,11 @@
 <file path=ppt/slideMasters/slideMaster1.xml><?xml version="1.0" encoding="utf-8"?>
 <p:sldMaster xmlns:a="http://schemas.openxmlformats.org/drawingml/2006/main" xmlns:r="http://schemas.openxmlformats.org/officeDocument/2006/relationships" xmlns:p="http://schemas.openxmlformats.org/presentationml/2006/main">
   <p:cSld>
+    <p:bg>
+      <p:bgRef idx="1001">
+        <a:schemeClr val="bg1"/>
+      </p:bgRef>
+    </p:bg>
     <p:spTree>
       <p:nvGrpSpPr>
         <p:cNvPr id="1" name=""/>
@@ -1660,6 +1436,7 @@
         <a:solidFill>
           <a:srgbClr val="0B1120"/>
         </a:solidFill>
+        <a:effectLst/>
       </p:bgPr>
     </p:bg>
     <p:spTree>
@@ -1739,11 +1516,11 @@
           <a:bodyPr wrap="square" rtlCol="0" anchor="ctr"/>
           <a:lstStyle/>
           <a:p>
-            <a:pPr indent="0" marL="0">
-              <a:buNone/>
-            </a:pPr>
-            <a:r>
-              <a:rPr lang="en-US" sz="1000" b="1" spc="600" kern="0" dirty="0">
+            <a:pPr marL="0" indent="0">
+              <a:buNone/>
+            </a:pPr>
+            <a:r>
+              <a:rPr lang="en-US" sz="1000" b="1" kern="0" spc="600" dirty="0">
                 <a:solidFill>
                   <a:srgbClr val="F97316"/>
                 </a:solidFill>
@@ -1778,7 +1555,7 @@
           <a:bodyPr wrap="square" rtlCol="0" anchor="ctr"/>
           <a:lstStyle/>
           <a:p>
-            <a:pPr indent="0" marL="0">
+            <a:pPr marL="0" indent="0">
               <a:buNone/>
             </a:pPr>
             <a:r>
@@ -1817,11 +1594,11 @@
           <a:bodyPr wrap="square" rtlCol="0" anchor="ctr"/>
           <a:lstStyle/>
           <a:p>
-            <a:pPr indent="0" marL="0">
-              <a:buNone/>
-            </a:pPr>
-            <a:r>
-              <a:rPr lang="en-US" sz="7200" b="1" spc="-200" kern="0" dirty="0">
+            <a:pPr marL="0" indent="0">
+              <a:buNone/>
+            </a:pPr>
+            <a:r>
+              <a:rPr lang="en-US" sz="7200" b="1" kern="0" spc="-200" dirty="0">
                 <a:solidFill>
                   <a:srgbClr val="F1F5F9"/>
                 </a:solidFill>
@@ -1856,11 +1633,11 @@
           <a:bodyPr wrap="square" rtlCol="0" anchor="ctr"/>
           <a:lstStyle/>
           <a:p>
-            <a:pPr indent="0" marL="0">
-              <a:buNone/>
-            </a:pPr>
-            <a:r>
-              <a:rPr lang="en-US" sz="2600" i="1" spc="-50" kern="0" dirty="0">
+            <a:pPr marL="0" indent="0">
+              <a:buNone/>
+            </a:pPr>
+            <a:r>
+              <a:rPr lang="en-US" sz="2600" i="1" kern="0" spc="-50" dirty="0">
                 <a:solidFill>
                   <a:srgbClr val="F97316"/>
                 </a:solidFill>
@@ -1895,7 +1672,7 @@
           <a:bodyPr wrap="square" rtlCol="0" anchor="ctr"/>
           <a:lstStyle/>
           <a:p>
-            <a:pPr indent="0" marL="0">
+            <a:pPr marL="0" indent="0">
               <a:buNone/>
             </a:pPr>
             <a:r>
@@ -1957,11 +1734,11 @@
           <a:bodyPr wrap="square" rtlCol="0" anchor="ctr"/>
           <a:lstStyle/>
           <a:p>
-            <a:pPr indent="0" marL="0">
-              <a:buNone/>
-            </a:pPr>
-            <a:r>
-              <a:rPr lang="en-US" sz="900" b="1" spc="400" kern="0" dirty="0">
+            <a:pPr marL="0" indent="0">
+              <a:buNone/>
+            </a:pPr>
+            <a:r>
+              <a:rPr lang="en-US" sz="900" b="1" kern="0" spc="400" dirty="0">
                 <a:solidFill>
                   <a:srgbClr val="64748B"/>
                 </a:solidFill>
@@ -1996,7 +1773,7 @@
           <a:bodyPr wrap="square" rtlCol="0" anchor="ctr"/>
           <a:lstStyle/>
           <a:p>
-            <a:pPr indent="0" marL="0">
+            <a:pPr marL="0" indent="0">
               <a:buNone/>
             </a:pPr>
             <a:r>
@@ -2035,7 +1812,7 @@
           <a:bodyPr wrap="square" rtlCol="0" anchor="ctr"/>
           <a:lstStyle/>
           <a:p>
-            <a:pPr indent="0" marL="0">
+            <a:pPr marL="0" indent="0">
               <a:buNone/>
             </a:pPr>
             <a:r>
@@ -2097,11 +1874,11 @@
           <a:bodyPr wrap="square" rtlCol="0" anchor="ctr"/>
           <a:lstStyle/>
           <a:p>
-            <a:pPr indent="0" marL="0">
-              <a:buNone/>
-            </a:pPr>
-            <a:r>
-              <a:rPr lang="en-US" sz="800" b="1" spc="300" kern="0" dirty="0">
+            <a:pPr marL="0" indent="0">
+              <a:buNone/>
+            </a:pPr>
+            <a:r>
+              <a:rPr lang="en-US" sz="800" b="1" kern="0" spc="300" dirty="0">
                 <a:solidFill>
                   <a:srgbClr val="64748B"/>
                 </a:solidFill>
@@ -2136,7 +1913,7 @@
           <a:bodyPr wrap="square" rtlCol="0" anchor="ctr"/>
           <a:lstStyle/>
           <a:p>
-            <a:pPr indent="0" marL="0">
+            <a:pPr marL="0" indent="0">
               <a:buNone/>
             </a:pPr>
             <a:r>
@@ -2159,6 +1936,18 @@
   <p:clrMapOvr>
     <a:masterClrMapping/>
   </p:clrMapOvr>
+  <mc:AlternateContent xmlns:mc="http://schemas.openxmlformats.org/markup-compatibility/2006">
+    <mc:Choice xmlns:p159="http://schemas.microsoft.com/office/powerpoint/2015/09/main" Requires="p159">
+      <p:transition xmlns:p14="http://schemas.microsoft.com/office/powerpoint/2010/main" spd="slow" p14:dur="2000">
+        <p159:morph option="byObject"/>
+      </p:transition>
+    </mc:Choice>
+    <mc:Fallback>
+      <p:transition spd="slow">
+        <p:fade/>
+      </p:transition>
+    </mc:Fallback>
+  </mc:AlternateContent>
 </p:sld>
 </file>
 
@@ -2170,6 +1959,7 @@
         <a:solidFill>
           <a:srgbClr val="0B1120"/>
         </a:solidFill>
+        <a:effectLst/>
       </p:bgPr>
     </p:bg>
     <p:spTree>
@@ -2271,11 +2061,11 @@
           <a:bodyPr wrap="square" rtlCol="0" anchor="ctr"/>
           <a:lstStyle/>
           <a:p>
-            <a:pPr indent="0" marL="0">
-              <a:buNone/>
-            </a:pPr>
-            <a:r>
-              <a:rPr lang="en-US" sz="1100" b="1" spc="800" kern="0" dirty="0">
+            <a:pPr marL="0" indent="0">
+              <a:buNone/>
+            </a:pPr>
+            <a:r>
+              <a:rPr lang="en-US" sz="1100" b="1" kern="0" spc="800" dirty="0">
                 <a:solidFill>
                   <a:srgbClr val="F97316"/>
                 </a:solidFill>
@@ -2310,11 +2100,11 @@
           <a:bodyPr wrap="square" rtlCol="0" anchor="ctr"/>
           <a:lstStyle/>
           <a:p>
-            <a:pPr indent="0" marL="0">
-              <a:buNone/>
-            </a:pPr>
-            <a:r>
-              <a:rPr lang="en-US" sz="9600" b="1" spc="-300" kern="0" dirty="0">
+            <a:pPr marL="0" indent="0">
+              <a:buNone/>
+            </a:pPr>
+            <a:r>
+              <a:rPr lang="en-US" sz="9600" b="1" kern="0" spc="-300" dirty="0">
                 <a:solidFill>
                   <a:srgbClr val="F1F5F9"/>
                 </a:solidFill>
@@ -2372,7 +2162,7 @@
           <a:bodyPr wrap="square" rtlCol="0" anchor="ctr"/>
           <a:lstStyle/>
           <a:p>
-            <a:pPr indent="0" marL="0">
+            <a:pPr marL="0" indent="0">
               <a:buNone/>
             </a:pPr>
             <a:r>
@@ -2434,11 +2224,11 @@
           <a:bodyPr wrap="square" rtlCol="0" anchor="ctr"/>
           <a:lstStyle/>
           <a:p>
-            <a:pPr indent="0" marL="0">
-              <a:buNone/>
-            </a:pPr>
-            <a:r>
-              <a:rPr lang="en-US" sz="900" b="1" spc="400" kern="0" dirty="0">
+            <a:pPr marL="0" indent="0">
+              <a:buNone/>
+            </a:pPr>
+            <a:r>
+              <a:rPr lang="en-US" sz="900" b="1" kern="0" spc="400" dirty="0">
                 <a:solidFill>
                   <a:srgbClr val="64748B"/>
                 </a:solidFill>
@@ -2473,7 +2263,7 @@
           <a:bodyPr wrap="square" rtlCol="0" anchor="ctr"/>
           <a:lstStyle/>
           <a:p>
-            <a:pPr indent="0" marL="0">
+            <a:pPr marL="0" indent="0">
               <a:buNone/>
             </a:pPr>
             <a:r>
@@ -2512,7 +2302,7 @@
           <a:bodyPr wrap="square" rtlCol="0" anchor="ctr"/>
           <a:lstStyle/>
           <a:p>
-            <a:pPr indent="0" marL="0">
+            <a:pPr marL="0" indent="0">
               <a:buNone/>
             </a:pPr>
             <a:r>
@@ -2535,6 +2325,18 @@
   <p:clrMapOvr>
     <a:masterClrMapping/>
   </p:clrMapOvr>
+  <mc:AlternateContent xmlns:mc="http://schemas.openxmlformats.org/markup-compatibility/2006">
+    <mc:Choice xmlns:p159="http://schemas.microsoft.com/office/powerpoint/2015/09/main" Requires="p159">
+      <p:transition xmlns:p14="http://schemas.microsoft.com/office/powerpoint/2010/main" spd="slow" p14:dur="2000">
+        <p159:morph option="byObject"/>
+      </p:transition>
+    </mc:Choice>
+    <mc:Fallback>
+      <p:transition spd="slow">
+        <p:fade/>
+      </p:transition>
+    </mc:Fallback>
+  </mc:AlternateContent>
 </p:sld>
 </file>
 
@@ -2546,6 +2348,7 @@
         <a:solidFill>
           <a:srgbClr val="0B1120"/>
         </a:solidFill>
+        <a:effectLst/>
       </p:bgPr>
     </p:bg>
     <p:spTree>
@@ -2583,11 +2386,11 @@
           <a:bodyPr wrap="square" rtlCol="0" anchor="ctr"/>
           <a:lstStyle/>
           <a:p>
-            <a:pPr indent="0" marL="0">
-              <a:buNone/>
-            </a:pPr>
-            <a:r>
-              <a:rPr lang="en-US" sz="900" b="1" spc="500" kern="0" dirty="0">
+            <a:pPr marL="0" indent="0">
+              <a:buNone/>
+            </a:pPr>
+            <a:r>
+              <a:rPr lang="en-US" sz="900" b="1" kern="0" spc="500" dirty="0">
                 <a:solidFill>
                   <a:srgbClr val="F97316"/>
                 </a:solidFill>
@@ -2622,11 +2425,11 @@
           <a:bodyPr wrap="square" rtlCol="0" anchor="ctr"/>
           <a:lstStyle/>
           <a:p>
-            <a:pPr indent="0" marL="0">
-              <a:buNone/>
-            </a:pPr>
-            <a:r>
-              <a:rPr lang="en-US" sz="900" spc="400" kern="0" dirty="0">
+            <a:pPr marL="0" indent="0">
+              <a:buNone/>
+            </a:pPr>
+            <a:r>
+              <a:rPr lang="en-US" sz="900" kern="0" spc="400" dirty="0">
                 <a:solidFill>
                   <a:srgbClr val="64748B"/>
                 </a:solidFill>
@@ -2661,7 +2464,7 @@
           <a:bodyPr wrap="square" rtlCol="0" anchor="ctr"/>
           <a:lstStyle/>
           <a:p>
-            <a:pPr algn="r" indent="0" marL="0">
+            <a:pPr marL="0" indent="0" algn="r">
               <a:buNone/>
             </a:pPr>
             <a:r>
@@ -2746,7 +2549,7 @@
           <a:bodyPr wrap="square" rtlCol="0" anchor="ctr"/>
           <a:lstStyle/>
           <a:p>
-            <a:pPr indent="0" marL="0">
+            <a:pPr marL="0" indent="0">
               <a:buNone/>
             </a:pPr>
             <a:r>
@@ -2785,7 +2588,7 @@
           <a:bodyPr wrap="square" rtlCol="0" anchor="ctr"/>
           <a:lstStyle/>
           <a:p>
-            <a:pPr algn="r" indent="0" marL="0">
+            <a:pPr marL="0" indent="0" algn="r">
               <a:buNone/>
             </a:pPr>
             <a:r>
@@ -2824,11 +2627,11 @@
           <a:bodyPr wrap="square" rtlCol="0" anchor="ctr"/>
           <a:lstStyle/>
           <a:p>
-            <a:pPr indent="0" marL="0">
-              <a:buNone/>
-            </a:pPr>
-            <a:r>
-              <a:rPr lang="en-US" sz="3000" b="1" spc="-50" kern="0" dirty="0">
+            <a:pPr marL="0" indent="0">
+              <a:buNone/>
+            </a:pPr>
+            <a:r>
+              <a:rPr lang="en-US" sz="3000" b="1" kern="0" spc="-50" dirty="0">
                 <a:solidFill>
                   <a:srgbClr val="F1F5F9"/>
                 </a:solidFill>
@@ -2863,7 +2666,7 @@
           <a:bodyPr wrap="square" rtlCol="0" anchor="ctr"/>
           <a:lstStyle/>
           <a:p>
-            <a:pPr indent="0" marL="0">
+            <a:pPr marL="0" indent="0">
               <a:buNone/>
             </a:pPr>
             <a:r>
@@ -2949,11 +2752,11 @@
           <a:bodyPr wrap="square" rtlCol="0" anchor="ctr"/>
           <a:lstStyle/>
           <a:p>
-            <a:pPr indent="0" marL="0">
-              <a:buNone/>
-            </a:pPr>
-            <a:r>
-              <a:rPr lang="en-US" sz="900" b="1" spc="300" kern="0" dirty="0">
+            <a:pPr marL="0" indent="0">
+              <a:buNone/>
+            </a:pPr>
+            <a:r>
+              <a:rPr lang="en-US" sz="900" b="1" kern="0" spc="300" dirty="0">
                 <a:solidFill>
                   <a:srgbClr val="F97316"/>
                 </a:solidFill>
@@ -2988,11 +2791,11 @@
           <a:bodyPr wrap="square" rtlCol="0" anchor="ctr"/>
           <a:lstStyle/>
           <a:p>
-            <a:pPr indent="0" marL="0">
-              <a:buNone/>
-            </a:pPr>
-            <a:r>
-              <a:rPr lang="en-US" sz="4200" b="1" spc="-100" kern="0" dirty="0">
+            <a:pPr marL="0" indent="0">
+              <a:buNone/>
+            </a:pPr>
+            <a:r>
+              <a:rPr lang="en-US" sz="4200" b="1" kern="0" spc="-100" dirty="0">
                 <a:solidFill>
                   <a:srgbClr val="F1F5F9"/>
                 </a:solidFill>
@@ -3027,7 +2830,7 @@
           <a:bodyPr wrap="square" rtlCol="0" anchor="ctr"/>
           <a:lstStyle/>
           <a:p>
-            <a:pPr indent="0" marL="0">
+            <a:pPr marL="0" indent="0">
               <a:buNone/>
             </a:pPr>
             <a:r>
@@ -3044,7 +2847,7 @@
             <a:endParaRPr lang="en-US" sz="1200" dirty="0"/>
           </a:p>
           <a:p>
-            <a:pPr indent="0" marL="0">
+            <a:pPr marL="0" indent="0">
               <a:buNone/>
             </a:pPr>
             <a:r>
@@ -3130,11 +2933,11 @@
           <a:bodyPr wrap="square" rtlCol="0" anchor="ctr"/>
           <a:lstStyle/>
           <a:p>
-            <a:pPr indent="0" marL="0">
-              <a:buNone/>
-            </a:pPr>
-            <a:r>
-              <a:rPr lang="en-US" sz="900" b="1" spc="300" kern="0" dirty="0">
+            <a:pPr marL="0" indent="0">
+              <a:buNone/>
+            </a:pPr>
+            <a:r>
+              <a:rPr lang="en-US" sz="900" b="1" kern="0" spc="300" dirty="0">
                 <a:solidFill>
                   <a:srgbClr val="38BDF8"/>
                 </a:solidFill>
@@ -3169,11 +2972,11 @@
           <a:bodyPr wrap="square" rtlCol="0" anchor="ctr"/>
           <a:lstStyle/>
           <a:p>
-            <a:pPr indent="0" marL="0">
-              <a:buNone/>
-            </a:pPr>
-            <a:r>
-              <a:rPr lang="en-US" sz="4200" b="1" spc="-100" kern="0" dirty="0">
+            <a:pPr marL="0" indent="0">
+              <a:buNone/>
+            </a:pPr>
+            <a:r>
+              <a:rPr lang="en-US" sz="4200" b="1" kern="0" spc="-100" dirty="0">
                 <a:solidFill>
                   <a:srgbClr val="F1F5F9"/>
                 </a:solidFill>
@@ -3208,7 +3011,7 @@
           <a:bodyPr wrap="square" rtlCol="0" anchor="ctr"/>
           <a:lstStyle/>
           <a:p>
-            <a:pPr indent="0" marL="0">
+            <a:pPr marL="0" indent="0">
               <a:buNone/>
             </a:pPr>
             <a:r>
@@ -3225,7 +3028,7 @@
             <a:endParaRPr lang="en-US" sz="1200" dirty="0"/>
           </a:p>
           <a:p>
-            <a:pPr indent="0" marL="0">
+            <a:pPr marL="0" indent="0">
               <a:buNone/>
             </a:pPr>
             <a:r>
@@ -3311,11 +3114,11 @@
           <a:bodyPr wrap="square" rtlCol="0" anchor="ctr"/>
           <a:lstStyle/>
           <a:p>
-            <a:pPr indent="0" marL="0">
-              <a:buNone/>
-            </a:pPr>
-            <a:r>
-              <a:rPr lang="en-US" sz="900" b="1" spc="300" kern="0" dirty="0">
+            <a:pPr marL="0" indent="0">
+              <a:buNone/>
+            </a:pPr>
+            <a:r>
+              <a:rPr lang="en-US" sz="900" b="1" kern="0" spc="300" dirty="0">
                 <a:solidFill>
                   <a:srgbClr val="A78BFA"/>
                 </a:solidFill>
@@ -3350,11 +3153,11 @@
           <a:bodyPr wrap="square" rtlCol="0" anchor="ctr"/>
           <a:lstStyle/>
           <a:p>
-            <a:pPr indent="0" marL="0">
-              <a:buNone/>
-            </a:pPr>
-            <a:r>
-              <a:rPr lang="en-US" sz="4200" b="1" spc="-100" kern="0" dirty="0">
+            <a:pPr marL="0" indent="0">
+              <a:buNone/>
+            </a:pPr>
+            <a:r>
+              <a:rPr lang="en-US" sz="4200" b="1" kern="0" spc="-100" dirty="0">
                 <a:solidFill>
                   <a:srgbClr val="F1F5F9"/>
                 </a:solidFill>
@@ -3389,7 +3192,7 @@
           <a:bodyPr wrap="square" rtlCol="0" anchor="ctr"/>
           <a:lstStyle/>
           <a:p>
-            <a:pPr indent="0" marL="0">
+            <a:pPr marL="0" indent="0">
               <a:buNone/>
             </a:pPr>
             <a:r>
@@ -3406,7 +3209,7 @@
             <a:endParaRPr lang="en-US" sz="1200" dirty="0"/>
           </a:p>
           <a:p>
-            <a:pPr indent="0" marL="0">
+            <a:pPr marL="0" indent="0">
               <a:buNone/>
             </a:pPr>
             <a:r>
@@ -3472,7 +3275,7 @@
           <a:bodyPr wrap="square" rtlCol="0" anchor="ctr"/>
           <a:lstStyle/>
           <a:p>
-            <a:pPr algn="ctr" indent="0" marL="0">
+            <a:pPr marL="0" indent="0" algn="ctr">
               <a:buNone/>
             </a:pPr>
             <a:r>
@@ -3486,9 +3289,6 @@
               </a:rPr>
               <a:t>"Cities can't fix what they can't measure.</a:t>
             </a:r>
-            <a:pPr algn="ctr" indent="0" marL="0">
-              <a:buNone/>
-            </a:pPr>
             <a:r>
               <a:rPr lang="en-US" sz="1700" i="1" dirty="0">
                 <a:solidFill>
@@ -3509,6 +3309,18 @@
   <p:clrMapOvr>
     <a:masterClrMapping/>
   </p:clrMapOvr>
+  <mc:AlternateContent xmlns:mc="http://schemas.openxmlformats.org/markup-compatibility/2006">
+    <mc:Choice xmlns:p159="http://schemas.microsoft.com/office/powerpoint/2015/09/main" Requires="p159">
+      <p:transition xmlns:p14="http://schemas.microsoft.com/office/powerpoint/2010/main" spd="slow" p14:dur="2000">
+        <p159:morph option="byObject"/>
+      </p:transition>
+    </mc:Choice>
+    <mc:Fallback>
+      <p:transition spd="slow">
+        <p:fade/>
+      </p:transition>
+    </mc:Fallback>
+  </mc:AlternateContent>
 </p:sld>
 </file>
 
@@ -3520,6 +3332,7 @@
         <a:solidFill>
           <a:srgbClr val="0B1120"/>
         </a:solidFill>
+        <a:effectLst/>
       </p:bgPr>
     </p:bg>
     <p:spTree>
@@ -3557,11 +3370,11 @@
           <a:bodyPr wrap="square" rtlCol="0" anchor="ctr"/>
           <a:lstStyle/>
           <a:p>
-            <a:pPr indent="0" marL="0">
-              <a:buNone/>
-            </a:pPr>
-            <a:r>
-              <a:rPr lang="en-US" sz="900" b="1" spc="500" kern="0" dirty="0">
+            <a:pPr marL="0" indent="0">
+              <a:buNone/>
+            </a:pPr>
+            <a:r>
+              <a:rPr lang="en-US" sz="900" b="1" kern="0" spc="500" dirty="0">
                 <a:solidFill>
                   <a:srgbClr val="F97316"/>
                 </a:solidFill>
@@ -3596,11 +3409,11 @@
           <a:bodyPr wrap="square" rtlCol="0" anchor="ctr"/>
           <a:lstStyle/>
           <a:p>
-            <a:pPr indent="0" marL="0">
-              <a:buNone/>
-            </a:pPr>
-            <a:r>
-              <a:rPr lang="en-US" sz="900" spc="400" kern="0" dirty="0">
+            <a:pPr marL="0" indent="0">
+              <a:buNone/>
+            </a:pPr>
+            <a:r>
+              <a:rPr lang="en-US" sz="900" kern="0" spc="400" dirty="0">
                 <a:solidFill>
                   <a:srgbClr val="64748B"/>
                 </a:solidFill>
@@ -3635,7 +3448,7 @@
           <a:bodyPr wrap="square" rtlCol="0" anchor="ctr"/>
           <a:lstStyle/>
           <a:p>
-            <a:pPr algn="r" indent="0" marL="0">
+            <a:pPr marL="0" indent="0" algn="r">
               <a:buNone/>
             </a:pPr>
             <a:r>
@@ -3720,7 +3533,7 @@
           <a:bodyPr wrap="square" rtlCol="0" anchor="ctr"/>
           <a:lstStyle/>
           <a:p>
-            <a:pPr indent="0" marL="0">
+            <a:pPr marL="0" indent="0">
               <a:buNone/>
             </a:pPr>
             <a:r>
@@ -3759,7 +3572,7 @@
           <a:bodyPr wrap="square" rtlCol="0" anchor="ctr"/>
           <a:lstStyle/>
           <a:p>
-            <a:pPr algn="r" indent="0" marL="0">
+            <a:pPr marL="0" indent="0" algn="r">
               <a:buNone/>
             </a:pPr>
             <a:r>
@@ -3798,11 +3611,11 @@
           <a:bodyPr wrap="square" rtlCol="0" anchor="ctr"/>
           <a:lstStyle/>
           <a:p>
-            <a:pPr indent="0" marL="0">
-              <a:buNone/>
-            </a:pPr>
-            <a:r>
-              <a:rPr lang="en-US" sz="3000" b="1" spc="-50" kern="0" dirty="0">
+            <a:pPr marL="0" indent="0">
+              <a:buNone/>
+            </a:pPr>
+            <a:r>
+              <a:rPr lang="en-US" sz="3000" b="1" kern="0" spc="-50" dirty="0">
                 <a:solidFill>
                   <a:srgbClr val="F1F5F9"/>
                 </a:solidFill>
@@ -3837,7 +3650,7 @@
           <a:bodyPr wrap="square" rtlCol="0" anchor="ctr"/>
           <a:lstStyle/>
           <a:p>
-            <a:pPr indent="0" marL="0">
+            <a:pPr marL="0" indent="0">
               <a:buNone/>
             </a:pPr>
             <a:r>
@@ -3903,11 +3716,11 @@
           <a:bodyPr wrap="square" rtlCol="0" anchor="ctr"/>
           <a:lstStyle/>
           <a:p>
-            <a:pPr indent="0" marL="0">
-              <a:buNone/>
-            </a:pPr>
-            <a:r>
-              <a:rPr lang="en-US" sz="4200" b="1" spc="-100" kern="0" dirty="0">
+            <a:pPr marL="0" indent="0">
+              <a:buNone/>
+            </a:pPr>
+            <a:r>
+              <a:rPr lang="en-US" sz="4200" b="1" kern="0" spc="-100" dirty="0">
                 <a:solidFill>
                   <a:srgbClr val="38BDF8"/>
                 </a:solidFill>
@@ -3942,11 +3755,11 @@
           <a:bodyPr wrap="square" rtlCol="0" anchor="ctr"/>
           <a:lstStyle/>
           <a:p>
-            <a:pPr indent="0" marL="0">
-              <a:buNone/>
-            </a:pPr>
-            <a:r>
-              <a:rPr lang="en-US" sz="1000" b="1" spc="400" kern="0" dirty="0">
+            <a:pPr marL="0" indent="0">
+              <a:buNone/>
+            </a:pPr>
+            <a:r>
+              <a:rPr lang="en-US" sz="1000" b="1" kern="0" spc="400" dirty="0">
                 <a:solidFill>
                   <a:srgbClr val="38BDF8"/>
                 </a:solidFill>
@@ -3981,7 +3794,7 @@
           <a:bodyPr wrap="square" rtlCol="0" anchor="ctr"/>
           <a:lstStyle/>
           <a:p>
-            <a:pPr indent="0" marL="0">
+            <a:pPr marL="0" indent="0">
               <a:buNone/>
             </a:pPr>
             <a:r>
@@ -4043,7 +3856,7 @@
           <a:bodyPr wrap="square" rtlCol="0" anchor="t"/>
           <a:lstStyle/>
           <a:p>
-            <a:pPr indent="0" marL="0">
+            <a:pPr marL="0" indent="0">
               <a:buNone/>
             </a:pPr>
             <a:r>
@@ -4109,11 +3922,11 @@
           <a:bodyPr wrap="square" rtlCol="0" anchor="ctr"/>
           <a:lstStyle/>
           <a:p>
-            <a:pPr indent="0" marL="0">
-              <a:buNone/>
-            </a:pPr>
-            <a:r>
-              <a:rPr lang="en-US" sz="4200" b="1" spc="-100" kern="0" dirty="0">
+            <a:pPr marL="0" indent="0">
+              <a:buNone/>
+            </a:pPr>
+            <a:r>
+              <a:rPr lang="en-US" sz="4200" b="1" kern="0" spc="-100" dirty="0">
                 <a:solidFill>
                   <a:srgbClr val="F97316"/>
                 </a:solidFill>
@@ -4148,11 +3961,11 @@
           <a:bodyPr wrap="square" rtlCol="0" anchor="ctr"/>
           <a:lstStyle/>
           <a:p>
-            <a:pPr indent="0" marL="0">
-              <a:buNone/>
-            </a:pPr>
-            <a:r>
-              <a:rPr lang="en-US" sz="1000" b="1" spc="400" kern="0" dirty="0">
+            <a:pPr marL="0" indent="0">
+              <a:buNone/>
+            </a:pPr>
+            <a:r>
+              <a:rPr lang="en-US" sz="1000" b="1" kern="0" spc="400" dirty="0">
                 <a:solidFill>
                   <a:srgbClr val="F97316"/>
                 </a:solidFill>
@@ -4187,7 +4000,7 @@
           <a:bodyPr wrap="square" rtlCol="0" anchor="ctr"/>
           <a:lstStyle/>
           <a:p>
-            <a:pPr indent="0" marL="0">
+            <a:pPr marL="0" indent="0">
               <a:buNone/>
             </a:pPr>
             <a:r>
@@ -4249,7 +4062,7 @@
           <a:bodyPr wrap="square" rtlCol="0" anchor="t"/>
           <a:lstStyle/>
           <a:p>
-            <a:pPr indent="0" marL="0">
+            <a:pPr marL="0" indent="0">
               <a:buNone/>
             </a:pPr>
             <a:r>
@@ -4315,11 +4128,11 @@
           <a:bodyPr wrap="square" rtlCol="0" anchor="ctr"/>
           <a:lstStyle/>
           <a:p>
-            <a:pPr indent="0" marL="0">
-              <a:buNone/>
-            </a:pPr>
-            <a:r>
-              <a:rPr lang="en-US" sz="4200" b="1" spc="-100" kern="0" dirty="0">
+            <a:pPr marL="0" indent="0">
+              <a:buNone/>
+            </a:pPr>
+            <a:r>
+              <a:rPr lang="en-US" sz="4200" b="1" kern="0" spc="-100" dirty="0">
                 <a:solidFill>
                   <a:srgbClr val="A78BFA"/>
                 </a:solidFill>
@@ -4354,11 +4167,11 @@
           <a:bodyPr wrap="square" rtlCol="0" anchor="ctr"/>
           <a:lstStyle/>
           <a:p>
-            <a:pPr indent="0" marL="0">
-              <a:buNone/>
-            </a:pPr>
-            <a:r>
-              <a:rPr lang="en-US" sz="1000" b="1" spc="400" kern="0" dirty="0">
+            <a:pPr marL="0" indent="0">
+              <a:buNone/>
+            </a:pPr>
+            <a:r>
+              <a:rPr lang="en-US" sz="1000" b="1" kern="0" spc="400" dirty="0">
                 <a:solidFill>
                   <a:srgbClr val="A78BFA"/>
                 </a:solidFill>
@@ -4393,7 +4206,7 @@
           <a:bodyPr wrap="square" rtlCol="0" anchor="ctr"/>
           <a:lstStyle/>
           <a:p>
-            <a:pPr indent="0" marL="0">
+            <a:pPr marL="0" indent="0">
               <a:buNone/>
             </a:pPr>
             <a:r>
@@ -4455,7 +4268,7 @@
           <a:bodyPr wrap="square" rtlCol="0" anchor="t"/>
           <a:lstStyle/>
           <a:p>
-            <a:pPr indent="0" marL="0">
+            <a:pPr marL="0" indent="0">
               <a:buNone/>
             </a:pPr>
             <a:r>
@@ -4478,6 +4291,18 @@
   <p:clrMapOvr>
     <a:masterClrMapping/>
   </p:clrMapOvr>
+  <mc:AlternateContent xmlns:mc="http://schemas.openxmlformats.org/markup-compatibility/2006">
+    <mc:Choice xmlns:p159="http://schemas.microsoft.com/office/powerpoint/2015/09/main" Requires="p159">
+      <p:transition xmlns:p14="http://schemas.microsoft.com/office/powerpoint/2010/main" spd="slow" p14:dur="2000">
+        <p159:morph option="byObject"/>
+      </p:transition>
+    </mc:Choice>
+    <mc:Fallback>
+      <p:transition spd="slow">
+        <p:fade/>
+      </p:transition>
+    </mc:Fallback>
+  </mc:AlternateContent>
 </p:sld>
 </file>
 
@@ -4489,6 +4314,7 @@
         <a:solidFill>
           <a:srgbClr val="0B1120"/>
         </a:solidFill>
+        <a:effectLst/>
       </p:bgPr>
     </p:bg>
     <p:spTree>
@@ -4526,11 +4352,11 @@
           <a:bodyPr wrap="square" rtlCol="0" anchor="ctr"/>
           <a:lstStyle/>
           <a:p>
-            <a:pPr indent="0" marL="0">
-              <a:buNone/>
-            </a:pPr>
-            <a:r>
-              <a:rPr lang="en-US" sz="900" b="1" spc="500" kern="0" dirty="0">
+            <a:pPr marL="0" indent="0">
+              <a:buNone/>
+            </a:pPr>
+            <a:r>
+              <a:rPr lang="en-US" sz="900" b="1" kern="0" spc="500" dirty="0">
                 <a:solidFill>
                   <a:srgbClr val="F97316"/>
                 </a:solidFill>
@@ -4565,11 +4391,11 @@
           <a:bodyPr wrap="square" rtlCol="0" anchor="ctr"/>
           <a:lstStyle/>
           <a:p>
-            <a:pPr indent="0" marL="0">
-              <a:buNone/>
-            </a:pPr>
-            <a:r>
-              <a:rPr lang="en-US" sz="900" spc="400" kern="0" dirty="0">
+            <a:pPr marL="0" indent="0">
+              <a:buNone/>
+            </a:pPr>
+            <a:r>
+              <a:rPr lang="en-US" sz="900" kern="0" spc="400" dirty="0">
                 <a:solidFill>
                   <a:srgbClr val="64748B"/>
                 </a:solidFill>
@@ -4604,7 +4430,7 @@
           <a:bodyPr wrap="square" rtlCol="0" anchor="ctr"/>
           <a:lstStyle/>
           <a:p>
-            <a:pPr algn="r" indent="0" marL="0">
+            <a:pPr marL="0" indent="0" algn="r">
               <a:buNone/>
             </a:pPr>
             <a:r>
@@ -4689,7 +4515,7 @@
           <a:bodyPr wrap="square" rtlCol="0" anchor="ctr"/>
           <a:lstStyle/>
           <a:p>
-            <a:pPr indent="0" marL="0">
+            <a:pPr marL="0" indent="0">
               <a:buNone/>
             </a:pPr>
             <a:r>
@@ -4728,7 +4554,7 @@
           <a:bodyPr wrap="square" rtlCol="0" anchor="ctr"/>
           <a:lstStyle/>
           <a:p>
-            <a:pPr algn="r" indent="0" marL="0">
+            <a:pPr marL="0" indent="0" algn="r">
               <a:buNone/>
             </a:pPr>
             <a:r>
@@ -4767,11 +4593,11 @@
           <a:bodyPr wrap="square" rtlCol="0" anchor="ctr"/>
           <a:lstStyle/>
           <a:p>
-            <a:pPr indent="0" marL="0">
-              <a:buNone/>
-            </a:pPr>
-            <a:r>
-              <a:rPr lang="en-US" sz="3000" b="1" spc="-50" kern="0" dirty="0">
+            <a:pPr marL="0" indent="0">
+              <a:buNone/>
+            </a:pPr>
+            <a:r>
+              <a:rPr lang="en-US" sz="3000" b="1" kern="0" spc="-50" dirty="0">
                 <a:solidFill>
                   <a:srgbClr val="F1F5F9"/>
                 </a:solidFill>
@@ -4806,7 +4632,7 @@
           <a:bodyPr wrap="square" rtlCol="0" anchor="ctr"/>
           <a:lstStyle/>
           <a:p>
-            <a:pPr indent="0" marL="0">
+            <a:pPr marL="0" indent="0">
               <a:buNone/>
             </a:pPr>
             <a:r>
@@ -4892,11 +4718,11 @@
           <a:bodyPr wrap="square" rtlCol="0" anchor="ctr"/>
           <a:lstStyle/>
           <a:p>
-            <a:pPr algn="ctr" indent="0" marL="0">
-              <a:buNone/>
-            </a:pPr>
-            <a:r>
-              <a:rPr lang="en-US" sz="1100" b="1" spc="200" kern="0" dirty="0">
+            <a:pPr marL="0" indent="0" algn="ctr">
+              <a:buNone/>
+            </a:pPr>
+            <a:r>
+              <a:rPr lang="en-US" sz="1100" b="1" kern="0" spc="200" dirty="0">
                 <a:solidFill>
                   <a:srgbClr val="F97316"/>
                 </a:solidFill>
@@ -4931,7 +4757,7 @@
           <a:bodyPr wrap="square" rtlCol="0" anchor="ctr"/>
           <a:lstStyle/>
           <a:p>
-            <a:pPr algn="ctr" indent="0" marL="0">
+            <a:pPr marL="0" indent="0" algn="ctr">
               <a:buNone/>
             </a:pPr>
             <a:r>
@@ -4993,7 +4819,7 @@
           <a:bodyPr wrap="square" rtlCol="0" anchor="t"/>
           <a:lstStyle/>
           <a:p>
-            <a:pPr algn="ctr" indent="0" marL="0">
+            <a:pPr marL="0" indent="0" algn="ctr">
               <a:buNone/>
             </a:pPr>
             <a:r>
@@ -5010,7 +4836,7 @@
             <a:endParaRPr lang="en-US" sz="1100" dirty="0"/>
           </a:p>
           <a:p>
-            <a:pPr algn="ctr" indent="0" marL="0">
+            <a:pPr marL="0" indent="0" algn="ctr">
               <a:buNone/>
             </a:pPr>
             <a:r>
@@ -5049,7 +4875,7 @@
           <a:bodyPr wrap="square" rtlCol="0" anchor="ctr"/>
           <a:lstStyle/>
           <a:p>
-            <a:pPr algn="ctr" indent="0" marL="0">
+            <a:pPr marL="0" indent="0" algn="ctr">
               <a:buNone/>
             </a:pPr>
             <a:r>
@@ -5132,11 +4958,11 @@
           <a:bodyPr wrap="square" rtlCol="0" anchor="ctr"/>
           <a:lstStyle/>
           <a:p>
-            <a:pPr algn="ctr" indent="0" marL="0">
-              <a:buNone/>
-            </a:pPr>
-            <a:r>
-              <a:rPr lang="en-US" sz="1100" b="1" spc="200" kern="0" dirty="0">
+            <a:pPr marL="0" indent="0" algn="ctr">
+              <a:buNone/>
+            </a:pPr>
+            <a:r>
+              <a:rPr lang="en-US" sz="1100" b="1" kern="0" spc="200" dirty="0">
                 <a:solidFill>
                   <a:srgbClr val="F97316"/>
                 </a:solidFill>
@@ -5171,7 +4997,7 @@
           <a:bodyPr wrap="square" rtlCol="0" anchor="ctr"/>
           <a:lstStyle/>
           <a:p>
-            <a:pPr algn="ctr" indent="0" marL="0">
+            <a:pPr marL="0" indent="0" algn="ctr">
               <a:buNone/>
             </a:pPr>
             <a:r>
@@ -5233,7 +5059,7 @@
           <a:bodyPr wrap="square" rtlCol="0" anchor="t"/>
           <a:lstStyle/>
           <a:p>
-            <a:pPr algn="ctr" indent="0" marL="0">
+            <a:pPr marL="0" indent="0" algn="ctr">
               <a:buNone/>
             </a:pPr>
             <a:r>
@@ -5250,7 +5076,7 @@
             <a:endParaRPr lang="en-US" sz="1100" dirty="0"/>
           </a:p>
           <a:p>
-            <a:pPr algn="ctr" indent="0" marL="0">
+            <a:pPr marL="0" indent="0" algn="ctr">
               <a:buNone/>
             </a:pPr>
             <a:r>
@@ -5289,7 +5115,7 @@
           <a:bodyPr wrap="square" rtlCol="0" anchor="ctr"/>
           <a:lstStyle/>
           <a:p>
-            <a:pPr algn="ctr" indent="0" marL="0">
+            <a:pPr marL="0" indent="0" algn="ctr">
               <a:buNone/>
             </a:pPr>
             <a:r>
@@ -5372,11 +5198,11 @@
           <a:bodyPr wrap="square" rtlCol="0" anchor="ctr"/>
           <a:lstStyle/>
           <a:p>
-            <a:pPr algn="ctr" indent="0" marL="0">
-              <a:buNone/>
-            </a:pPr>
-            <a:r>
-              <a:rPr lang="en-US" sz="1100" b="1" spc="200" kern="0" dirty="0">
+            <a:pPr marL="0" indent="0" algn="ctr">
+              <a:buNone/>
+            </a:pPr>
+            <a:r>
+              <a:rPr lang="en-US" sz="1100" b="1" kern="0" spc="200" dirty="0">
                 <a:solidFill>
                   <a:srgbClr val="F97316"/>
                 </a:solidFill>
@@ -5411,7 +5237,7 @@
           <a:bodyPr wrap="square" rtlCol="0" anchor="ctr"/>
           <a:lstStyle/>
           <a:p>
-            <a:pPr algn="ctr" indent="0" marL="0">
+            <a:pPr marL="0" indent="0" algn="ctr">
               <a:buNone/>
             </a:pPr>
             <a:r>
@@ -5473,7 +5299,7 @@
           <a:bodyPr wrap="square" rtlCol="0" anchor="t"/>
           <a:lstStyle/>
           <a:p>
-            <a:pPr algn="ctr" indent="0" marL="0">
+            <a:pPr marL="0" indent="0" algn="ctr">
               <a:buNone/>
             </a:pPr>
             <a:r>
@@ -5490,7 +5316,7 @@
             <a:endParaRPr lang="en-US" sz="1100" dirty="0"/>
           </a:p>
           <a:p>
-            <a:pPr algn="ctr" indent="0" marL="0">
+            <a:pPr marL="0" indent="0" algn="ctr">
               <a:buNone/>
             </a:pPr>
             <a:r>
@@ -5529,7 +5355,7 @@
           <a:bodyPr wrap="square" rtlCol="0" anchor="ctr"/>
           <a:lstStyle/>
           <a:p>
-            <a:pPr algn="ctr" indent="0" marL="0">
+            <a:pPr marL="0" indent="0" algn="ctr">
               <a:buNone/>
             </a:pPr>
             <a:r>
@@ -5612,11 +5438,11 @@
           <a:bodyPr wrap="square" rtlCol="0" anchor="ctr"/>
           <a:lstStyle/>
           <a:p>
-            <a:pPr algn="ctr" indent="0" marL="0">
-              <a:buNone/>
-            </a:pPr>
-            <a:r>
-              <a:rPr lang="en-US" sz="1100" b="1" spc="200" kern="0" dirty="0">
+            <a:pPr marL="0" indent="0" algn="ctr">
+              <a:buNone/>
+            </a:pPr>
+            <a:r>
+              <a:rPr lang="en-US" sz="1100" b="1" kern="0" spc="200" dirty="0">
                 <a:solidFill>
                   <a:srgbClr val="F97316"/>
                 </a:solidFill>
@@ -5651,7 +5477,7 @@
           <a:bodyPr wrap="square" rtlCol="0" anchor="ctr"/>
           <a:lstStyle/>
           <a:p>
-            <a:pPr algn="ctr" indent="0" marL="0">
+            <a:pPr marL="0" indent="0" algn="ctr">
               <a:buNone/>
             </a:pPr>
             <a:r>
@@ -5713,7 +5539,7 @@
           <a:bodyPr wrap="square" rtlCol="0" anchor="t"/>
           <a:lstStyle/>
           <a:p>
-            <a:pPr algn="ctr" indent="0" marL="0">
+            <a:pPr marL="0" indent="0" algn="ctr">
               <a:buNone/>
             </a:pPr>
             <a:r>
@@ -5730,7 +5556,7 @@
             <a:endParaRPr lang="en-US" sz="1100" dirty="0"/>
           </a:p>
           <a:p>
-            <a:pPr algn="ctr" indent="0" marL="0">
+            <a:pPr marL="0" indent="0" algn="ctr">
               <a:buNone/>
             </a:pPr>
             <a:r>
@@ -5769,7 +5595,7 @@
           <a:bodyPr wrap="square" rtlCol="0" anchor="ctr"/>
           <a:lstStyle/>
           <a:p>
-            <a:pPr algn="ctr" indent="0" marL="0">
+            <a:pPr marL="0" indent="0" algn="ctr">
               <a:buNone/>
             </a:pPr>
             <a:r>
@@ -5852,11 +5678,11 @@
           <a:bodyPr wrap="square" rtlCol="0" anchor="ctr"/>
           <a:lstStyle/>
           <a:p>
-            <a:pPr algn="ctr" indent="0" marL="0">
-              <a:buNone/>
-            </a:pPr>
-            <a:r>
-              <a:rPr lang="en-US" sz="1100" b="1" spc="200" kern="0" dirty="0">
+            <a:pPr marL="0" indent="0" algn="ctr">
+              <a:buNone/>
+            </a:pPr>
+            <a:r>
+              <a:rPr lang="en-US" sz="1100" b="1" kern="0" spc="200" dirty="0">
                 <a:solidFill>
                   <a:srgbClr val="F97316"/>
                 </a:solidFill>
@@ -5891,7 +5717,7 @@
           <a:bodyPr wrap="square" rtlCol="0" anchor="ctr"/>
           <a:lstStyle/>
           <a:p>
-            <a:pPr algn="ctr" indent="0" marL="0">
+            <a:pPr marL="0" indent="0" algn="ctr">
               <a:buNone/>
             </a:pPr>
             <a:r>
@@ -5953,7 +5779,7 @@
           <a:bodyPr wrap="square" rtlCol="0" anchor="t"/>
           <a:lstStyle/>
           <a:p>
-            <a:pPr algn="ctr" indent="0" marL="0">
+            <a:pPr marL="0" indent="0" algn="ctr">
               <a:buNone/>
             </a:pPr>
             <a:r>
@@ -5970,7 +5796,7 @@
             <a:endParaRPr lang="en-US" sz="1100" dirty="0"/>
           </a:p>
           <a:p>
-            <a:pPr algn="ctr" indent="0" marL="0">
+            <a:pPr marL="0" indent="0" algn="ctr">
               <a:buNone/>
             </a:pPr>
             <a:r>
@@ -6009,7 +5835,7 @@
           <a:bodyPr wrap="square" rtlCol="0" anchor="ctr"/>
           <a:lstStyle/>
           <a:p>
-            <a:pPr algn="ctr" indent="0" marL="0">
+            <a:pPr marL="0" indent="0" algn="ctr">
               <a:buNone/>
             </a:pPr>
             <a:r>
@@ -6092,11 +5918,11 @@
           <a:bodyPr wrap="square" rtlCol="0" anchor="ctr"/>
           <a:lstStyle/>
           <a:p>
-            <a:pPr algn="ctr" indent="0" marL="0">
-              <a:buNone/>
-            </a:pPr>
-            <a:r>
-              <a:rPr lang="en-US" sz="1100" b="1" spc="200" kern="0" dirty="0">
+            <a:pPr marL="0" indent="0" algn="ctr">
+              <a:buNone/>
+            </a:pPr>
+            <a:r>
+              <a:rPr lang="en-US" sz="1100" b="1" kern="0" spc="200" dirty="0">
                 <a:solidFill>
                   <a:srgbClr val="F97316"/>
                 </a:solidFill>
@@ -6131,7 +5957,7 @@
           <a:bodyPr wrap="square" rtlCol="0" anchor="ctr"/>
           <a:lstStyle/>
           <a:p>
-            <a:pPr algn="ctr" indent="0" marL="0">
+            <a:pPr marL="0" indent="0" algn="ctr">
               <a:buNone/>
             </a:pPr>
             <a:r>
@@ -6193,7 +6019,7 @@
           <a:bodyPr wrap="square" rtlCol="0" anchor="t"/>
           <a:lstStyle/>
           <a:p>
-            <a:pPr algn="ctr" indent="0" marL="0">
+            <a:pPr marL="0" indent="0" algn="ctr">
               <a:buNone/>
             </a:pPr>
             <a:r>
@@ -6210,7 +6036,7 @@
             <a:endParaRPr lang="en-US" sz="1100" dirty="0"/>
           </a:p>
           <a:p>
-            <a:pPr algn="ctr" indent="0" marL="0">
+            <a:pPr marL="0" indent="0" algn="ctr">
               <a:buNone/>
             </a:pPr>
             <a:r>
@@ -6296,7 +6122,7 @@
           <a:bodyPr wrap="square" rtlCol="0" anchor="ctr"/>
           <a:lstStyle/>
           <a:p>
-            <a:pPr indent="0" marL="0">
+            <a:pPr marL="0" indent="0">
               <a:buNone/>
             </a:pPr>
             <a:r>
@@ -6335,7 +6161,7 @@
           <a:bodyPr wrap="square" rtlCol="0" anchor="t"/>
           <a:lstStyle/>
           <a:p>
-            <a:pPr indent="0" marL="0">
+            <a:pPr marL="0" indent="0">
               <a:buNone/>
             </a:pPr>
             <a:r>
@@ -6421,7 +6247,7 @@
           <a:bodyPr wrap="square" rtlCol="0" anchor="ctr"/>
           <a:lstStyle/>
           <a:p>
-            <a:pPr indent="0" marL="0">
+            <a:pPr marL="0" indent="0">
               <a:buNone/>
             </a:pPr>
             <a:r>
@@ -6460,7 +6286,7 @@
           <a:bodyPr wrap="square" rtlCol="0" anchor="t"/>
           <a:lstStyle/>
           <a:p>
-            <a:pPr indent="0" marL="0">
+            <a:pPr marL="0" indent="0">
               <a:buNone/>
             </a:pPr>
             <a:r>
@@ -6483,6 +6309,18 @@
   <p:clrMapOvr>
     <a:masterClrMapping/>
   </p:clrMapOvr>
+  <mc:AlternateContent xmlns:mc="http://schemas.openxmlformats.org/markup-compatibility/2006">
+    <mc:Choice xmlns:p159="http://schemas.microsoft.com/office/powerpoint/2015/09/main" Requires="p159">
+      <p:transition xmlns:p14="http://schemas.microsoft.com/office/powerpoint/2010/main" spd="slow" p14:dur="2000">
+        <p159:morph option="byObject"/>
+      </p:transition>
+    </mc:Choice>
+    <mc:Fallback>
+      <p:transition spd="slow">
+        <p:fade/>
+      </p:transition>
+    </mc:Fallback>
+  </mc:AlternateContent>
 </p:sld>
 </file>
 
@@ -6494,6 +6332,7 @@
         <a:solidFill>
           <a:srgbClr val="0B1120"/>
         </a:solidFill>
+        <a:effectLst/>
       </p:bgPr>
     </p:bg>
     <p:spTree>
@@ -6531,11 +6370,11 @@
           <a:bodyPr wrap="square" rtlCol="0" anchor="ctr"/>
           <a:lstStyle/>
           <a:p>
-            <a:pPr indent="0" marL="0">
-              <a:buNone/>
-            </a:pPr>
-            <a:r>
-              <a:rPr lang="en-US" sz="900" b="1" spc="500" kern="0" dirty="0">
+            <a:pPr marL="0" indent="0">
+              <a:buNone/>
+            </a:pPr>
+            <a:r>
+              <a:rPr lang="en-US" sz="900" b="1" kern="0" spc="500" dirty="0">
                 <a:solidFill>
                   <a:srgbClr val="F97316"/>
                 </a:solidFill>
@@ -6570,11 +6409,11 @@
           <a:bodyPr wrap="square" rtlCol="0" anchor="ctr"/>
           <a:lstStyle/>
           <a:p>
-            <a:pPr indent="0" marL="0">
-              <a:buNone/>
-            </a:pPr>
-            <a:r>
-              <a:rPr lang="en-US" sz="900" spc="400" kern="0" dirty="0">
+            <a:pPr marL="0" indent="0">
+              <a:buNone/>
+            </a:pPr>
+            <a:r>
+              <a:rPr lang="en-US" sz="900" kern="0" spc="400" dirty="0">
                 <a:solidFill>
                   <a:srgbClr val="64748B"/>
                 </a:solidFill>
@@ -6609,7 +6448,7 @@
           <a:bodyPr wrap="square" rtlCol="0" anchor="ctr"/>
           <a:lstStyle/>
           <a:p>
-            <a:pPr algn="r" indent="0" marL="0">
+            <a:pPr marL="0" indent="0" algn="r">
               <a:buNone/>
             </a:pPr>
             <a:r>
@@ -6694,7 +6533,7 @@
           <a:bodyPr wrap="square" rtlCol="0" anchor="ctr"/>
           <a:lstStyle/>
           <a:p>
-            <a:pPr indent="0" marL="0">
+            <a:pPr marL="0" indent="0">
               <a:buNone/>
             </a:pPr>
             <a:r>
@@ -6733,7 +6572,7 @@
           <a:bodyPr wrap="square" rtlCol="0" anchor="ctr"/>
           <a:lstStyle/>
           <a:p>
-            <a:pPr algn="r" indent="0" marL="0">
+            <a:pPr marL="0" indent="0" algn="r">
               <a:buNone/>
             </a:pPr>
             <a:r>
@@ -6772,11 +6611,11 @@
           <a:bodyPr wrap="square" rtlCol="0" anchor="ctr"/>
           <a:lstStyle/>
           <a:p>
-            <a:pPr indent="0" marL="0">
-              <a:buNone/>
-            </a:pPr>
-            <a:r>
-              <a:rPr lang="en-US" sz="3000" b="1" spc="-50" kern="0" dirty="0">
+            <a:pPr marL="0" indent="0">
+              <a:buNone/>
+            </a:pPr>
+            <a:r>
+              <a:rPr lang="en-US" sz="3000" b="1" kern="0" spc="-50" dirty="0">
                 <a:solidFill>
                   <a:srgbClr val="F1F5F9"/>
                 </a:solidFill>
@@ -6811,7 +6650,7 @@
           <a:bodyPr wrap="square" rtlCol="0" anchor="ctr"/>
           <a:lstStyle/>
           <a:p>
-            <a:pPr indent="0" marL="0">
+            <a:pPr marL="0" indent="0">
               <a:buNone/>
             </a:pPr>
             <a:r>
@@ -6877,11 +6716,11 @@
           <a:bodyPr wrap="square" rtlCol="0" anchor="ctr"/>
           <a:lstStyle/>
           <a:p>
-            <a:pPr indent="0" marL="0">
-              <a:buNone/>
-            </a:pPr>
-            <a:r>
-              <a:rPr lang="en-US" sz="1100" b="1" spc="500" kern="0" dirty="0">
+            <a:pPr marL="0" indent="0">
+              <a:buNone/>
+            </a:pPr>
+            <a:r>
+              <a:rPr lang="en-US" sz="1100" b="1" kern="0" spc="500" dirty="0">
                 <a:solidFill>
                   <a:srgbClr val="38BDF8"/>
                 </a:solidFill>
@@ -6959,7 +6798,7 @@
           <a:bodyPr wrap="square" rtlCol="0" anchor="ctr"/>
           <a:lstStyle/>
           <a:p>
-            <a:pPr indent="0" marL="0">
+            <a:pPr marL="0" indent="0">
               <a:buNone/>
             </a:pPr>
             <a:r>
@@ -7018,7 +6857,7 @@
           <a:bodyPr wrap="square" rtlCol="0" anchor="ctr"/>
           <a:lstStyle/>
           <a:p>
-            <a:pPr indent="0" marL="0">
+            <a:pPr marL="0" indent="0">
               <a:buNone/>
             </a:pPr>
             <a:r>
@@ -7077,7 +6916,7 @@
           <a:bodyPr wrap="square" rtlCol="0" anchor="ctr"/>
           <a:lstStyle/>
           <a:p>
-            <a:pPr indent="0" marL="0">
+            <a:pPr marL="0" indent="0">
               <a:buNone/>
             </a:pPr>
             <a:r>
@@ -7136,7 +6975,7 @@
           <a:bodyPr wrap="square" rtlCol="0" anchor="ctr"/>
           <a:lstStyle/>
           <a:p>
-            <a:pPr indent="0" marL="0">
+            <a:pPr marL="0" indent="0">
               <a:buNone/>
             </a:pPr>
             <a:r>
@@ -7195,7 +7034,7 @@
           <a:bodyPr wrap="square" rtlCol="0" anchor="ctr"/>
           <a:lstStyle/>
           <a:p>
-            <a:pPr indent="0" marL="0">
+            <a:pPr marL="0" indent="0">
               <a:buNone/>
             </a:pPr>
             <a:r>
@@ -7261,11 +7100,11 @@
           <a:bodyPr wrap="square" rtlCol="0" anchor="ctr"/>
           <a:lstStyle/>
           <a:p>
-            <a:pPr indent="0" marL="0">
-              <a:buNone/>
-            </a:pPr>
-            <a:r>
-              <a:rPr lang="en-US" sz="1100" b="1" spc="500" kern="0" dirty="0">
+            <a:pPr marL="0" indent="0">
+              <a:buNone/>
+            </a:pPr>
+            <a:r>
+              <a:rPr lang="en-US" sz="1100" b="1" kern="0" spc="500" dirty="0">
                 <a:solidFill>
                   <a:srgbClr val="F97316"/>
                 </a:solidFill>
@@ -7343,7 +7182,7 @@
           <a:bodyPr wrap="square" rtlCol="0" anchor="ctr"/>
           <a:lstStyle/>
           <a:p>
-            <a:pPr indent="0" marL="0">
+            <a:pPr marL="0" indent="0">
               <a:buNone/>
             </a:pPr>
             <a:r>
@@ -7402,7 +7241,7 @@
           <a:bodyPr wrap="square" rtlCol="0" anchor="ctr"/>
           <a:lstStyle/>
           <a:p>
-            <a:pPr indent="0" marL="0">
+            <a:pPr marL="0" indent="0">
               <a:buNone/>
             </a:pPr>
             <a:r>
@@ -7461,7 +7300,7 @@
           <a:bodyPr wrap="square" rtlCol="0" anchor="ctr"/>
           <a:lstStyle/>
           <a:p>
-            <a:pPr indent="0" marL="0">
+            <a:pPr marL="0" indent="0">
               <a:buNone/>
             </a:pPr>
             <a:r>
@@ -7520,7 +7359,7 @@
           <a:bodyPr wrap="square" rtlCol="0" anchor="ctr"/>
           <a:lstStyle/>
           <a:p>
-            <a:pPr indent="0" marL="0">
+            <a:pPr marL="0" indent="0">
               <a:buNone/>
             </a:pPr>
             <a:r>
@@ -7579,7 +7418,7 @@
           <a:bodyPr wrap="square" rtlCol="0" anchor="ctr"/>
           <a:lstStyle/>
           <a:p>
-            <a:pPr indent="0" marL="0">
+            <a:pPr marL="0" indent="0">
               <a:buNone/>
             </a:pPr>
             <a:r>
@@ -7645,11 +7484,11 @@
           <a:bodyPr wrap="square" rtlCol="0" anchor="ctr"/>
           <a:lstStyle/>
           <a:p>
-            <a:pPr indent="0" marL="0">
-              <a:buNone/>
-            </a:pPr>
-            <a:r>
-              <a:rPr lang="en-US" sz="1100" b="1" spc="500" kern="0" dirty="0">
+            <a:pPr marL="0" indent="0">
+              <a:buNone/>
+            </a:pPr>
+            <a:r>
+              <a:rPr lang="en-US" sz="1100" b="1" kern="0" spc="500" dirty="0">
                 <a:solidFill>
                   <a:srgbClr val="A78BFA"/>
                 </a:solidFill>
@@ -7727,7 +7566,7 @@
           <a:bodyPr wrap="square" rtlCol="0" anchor="ctr"/>
           <a:lstStyle/>
           <a:p>
-            <a:pPr indent="0" marL="0">
+            <a:pPr marL="0" indent="0">
               <a:buNone/>
             </a:pPr>
             <a:r>
@@ -7786,7 +7625,7 @@
           <a:bodyPr wrap="square" rtlCol="0" anchor="ctr"/>
           <a:lstStyle/>
           <a:p>
-            <a:pPr indent="0" marL="0">
+            <a:pPr marL="0" indent="0">
               <a:buNone/>
             </a:pPr>
             <a:r>
@@ -7845,7 +7684,7 @@
           <a:bodyPr wrap="square" rtlCol="0" anchor="ctr"/>
           <a:lstStyle/>
           <a:p>
-            <a:pPr indent="0" marL="0">
+            <a:pPr marL="0" indent="0">
               <a:buNone/>
             </a:pPr>
             <a:r>
@@ -7904,7 +7743,7 @@
           <a:bodyPr wrap="square" rtlCol="0" anchor="ctr"/>
           <a:lstStyle/>
           <a:p>
-            <a:pPr indent="0" marL="0">
+            <a:pPr marL="0" indent="0">
               <a:buNone/>
             </a:pPr>
             <a:r>
@@ -7963,7 +7802,7 @@
           <a:bodyPr wrap="square" rtlCol="0" anchor="ctr"/>
           <a:lstStyle/>
           <a:p>
-            <a:pPr indent="0" marL="0">
+            <a:pPr marL="0" indent="0">
               <a:buNone/>
             </a:pPr>
             <a:r>
@@ -7986,6 +7825,18 @@
   <p:clrMapOvr>
     <a:masterClrMapping/>
   </p:clrMapOvr>
+  <mc:AlternateContent xmlns:mc="http://schemas.openxmlformats.org/markup-compatibility/2006">
+    <mc:Choice xmlns:p159="http://schemas.microsoft.com/office/powerpoint/2015/09/main" Requires="p159">
+      <p:transition xmlns:p14="http://schemas.microsoft.com/office/powerpoint/2010/main" spd="slow" p14:dur="2000">
+        <p159:morph option="byObject"/>
+      </p:transition>
+    </mc:Choice>
+    <mc:Fallback>
+      <p:transition spd="slow">
+        <p:fade/>
+      </p:transition>
+    </mc:Fallback>
+  </mc:AlternateContent>
 </p:sld>
 </file>
 
@@ -7997,6 +7848,7 @@
         <a:solidFill>
           <a:srgbClr val="0B1120"/>
         </a:solidFill>
+        <a:effectLst/>
       </p:bgPr>
     </p:bg>
     <p:spTree>
@@ -8034,11 +7886,11 @@
           <a:bodyPr wrap="square" rtlCol="0" anchor="ctr"/>
           <a:lstStyle/>
           <a:p>
-            <a:pPr indent="0" marL="0">
-              <a:buNone/>
-            </a:pPr>
-            <a:r>
-              <a:rPr lang="en-US" sz="900" b="1" spc="500" kern="0" dirty="0">
+            <a:pPr marL="0" indent="0">
+              <a:buNone/>
+            </a:pPr>
+            <a:r>
+              <a:rPr lang="en-US" sz="900" b="1" kern="0" spc="500" dirty="0">
                 <a:solidFill>
                   <a:srgbClr val="F97316"/>
                 </a:solidFill>
@@ -8073,11 +7925,11 @@
           <a:bodyPr wrap="square" rtlCol="0" anchor="ctr"/>
           <a:lstStyle/>
           <a:p>
-            <a:pPr indent="0" marL="0">
-              <a:buNone/>
-            </a:pPr>
-            <a:r>
-              <a:rPr lang="en-US" sz="900" spc="400" kern="0" dirty="0">
+            <a:pPr marL="0" indent="0">
+              <a:buNone/>
+            </a:pPr>
+            <a:r>
+              <a:rPr lang="en-US" sz="900" kern="0" spc="400" dirty="0">
                 <a:solidFill>
                   <a:srgbClr val="64748B"/>
                 </a:solidFill>
@@ -8112,7 +7964,7 @@
           <a:bodyPr wrap="square" rtlCol="0" anchor="ctr"/>
           <a:lstStyle/>
           <a:p>
-            <a:pPr algn="r" indent="0" marL="0">
+            <a:pPr marL="0" indent="0" algn="r">
               <a:buNone/>
             </a:pPr>
             <a:r>
@@ -8197,7 +8049,7 @@
           <a:bodyPr wrap="square" rtlCol="0" anchor="ctr"/>
           <a:lstStyle/>
           <a:p>
-            <a:pPr indent="0" marL="0">
+            <a:pPr marL="0" indent="0">
               <a:buNone/>
             </a:pPr>
             <a:r>
@@ -8236,7 +8088,7 @@
           <a:bodyPr wrap="square" rtlCol="0" anchor="ctr"/>
           <a:lstStyle/>
           <a:p>
-            <a:pPr algn="r" indent="0" marL="0">
+            <a:pPr marL="0" indent="0" algn="r">
               <a:buNone/>
             </a:pPr>
             <a:r>
@@ -8275,11 +8127,11 @@
           <a:bodyPr wrap="square" rtlCol="0" anchor="ctr"/>
           <a:lstStyle/>
           <a:p>
-            <a:pPr indent="0" marL="0">
-              <a:buNone/>
-            </a:pPr>
-            <a:r>
-              <a:rPr lang="en-US" sz="3000" b="1" spc="-50" kern="0" dirty="0">
+            <a:pPr marL="0" indent="0">
+              <a:buNone/>
+            </a:pPr>
+            <a:r>
+              <a:rPr lang="en-US" sz="3000" b="1" kern="0" spc="-50" dirty="0">
                 <a:solidFill>
                   <a:srgbClr val="F1F5F9"/>
                 </a:solidFill>
@@ -8314,7 +8166,7 @@
           <a:bodyPr wrap="square" rtlCol="0" anchor="ctr"/>
           <a:lstStyle/>
           <a:p>
-            <a:pPr indent="0" marL="0">
+            <a:pPr marL="0" indent="0">
               <a:buNone/>
             </a:pPr>
             <a:r>
@@ -8334,15 +8186,15 @@
       </p:sp>
       <p:pic>
         <p:nvPicPr>
-          <p:cNvPr id="11" name="Image 0" descr="D:\Projects\IBM Internship\backend\static\outputs\severity_img_1783839683_input_image.png">    </p:cNvPr>
+          <p:cNvPr id="11" name="Image 0" descr="D:\Projects\IBM Internship\backend\static\outputs\severity_img_1783839683_input_image.png"/>
           <p:cNvPicPr>
             <a:picLocks noChangeAspect="1"/>
           </p:cNvPicPr>
           <p:nvPr/>
         </p:nvPicPr>
         <p:blipFill>
-          <a:blip r:embed="rId1"/>
-          <a:srcRect l="0" r="0" t="0" b="0"/>
+          <a:blip r:embed="rId3"/>
+          <a:srcRect/>
           <a:stretch/>
         </p:blipFill>
         <p:spPr>
@@ -8376,7 +8228,7 @@
           <a:bodyPr wrap="square" rtlCol="0" anchor="ctr"/>
           <a:lstStyle/>
           <a:p>
-            <a:pPr algn="ctr" indent="0" marL="0">
+            <a:pPr marL="0" indent="0" algn="ctr">
               <a:buNone/>
             </a:pPr>
             <a:r>
@@ -8442,11 +8294,11 @@
           <a:bodyPr wrap="square" rtlCol="0" anchor="ctr"/>
           <a:lstStyle/>
           <a:p>
-            <a:pPr indent="0" marL="0">
-              <a:buNone/>
-            </a:pPr>
-            <a:r>
-              <a:rPr lang="en-US" sz="1000" b="1" spc="300" kern="0" dirty="0">
+            <a:pPr marL="0" indent="0">
+              <a:buNone/>
+            </a:pPr>
+            <a:r>
+              <a:rPr lang="en-US" sz="1000" b="1" kern="0" spc="300" dirty="0">
                 <a:solidFill>
                   <a:srgbClr val="64748B"/>
                 </a:solidFill>
@@ -8481,11 +8333,11 @@
           <a:bodyPr wrap="square" rtlCol="0" anchor="ctr"/>
           <a:lstStyle/>
           <a:p>
-            <a:pPr indent="0" marL="0">
-              <a:buNone/>
-            </a:pPr>
-            <a:r>
-              <a:rPr lang="en-US" sz="5400" b="1" spc="-200" kern="0" dirty="0">
+            <a:pPr marL="0" indent="0">
+              <a:buNone/>
+            </a:pPr>
+            <a:r>
+              <a:rPr lang="en-US" sz="5400" b="1" kern="0" spc="-200" dirty="0">
                 <a:solidFill>
                   <a:srgbClr val="22C55E"/>
                 </a:solidFill>
@@ -8495,9 +8347,6 @@
               </a:rPr>
               <a:t>91.23</a:t>
             </a:r>
-            <a:pPr indent="0" marL="0">
-              <a:buNone/>
-            </a:pPr>
             <a:r>
               <a:rPr lang="en-US" sz="3200" b="1" dirty="0">
                 <a:solidFill>
@@ -8534,7 +8383,7 @@
           <a:bodyPr wrap="square" rtlCol="0" anchor="ctr"/>
           <a:lstStyle/>
           <a:p>
-            <a:pPr indent="0" marL="0">
+            <a:pPr marL="0" indent="0">
               <a:buNone/>
             </a:pPr>
             <a:r>
@@ -8600,11 +8449,11 @@
           <a:bodyPr wrap="square" rtlCol="0" anchor="ctr"/>
           <a:lstStyle/>
           <a:p>
-            <a:pPr indent="0" marL="0">
-              <a:buNone/>
-            </a:pPr>
-            <a:r>
-              <a:rPr lang="en-US" sz="1000" b="1" spc="300" kern="0" dirty="0">
+            <a:pPr marL="0" indent="0">
+              <a:buNone/>
+            </a:pPr>
+            <a:r>
+              <a:rPr lang="en-US" sz="1000" b="1" kern="0" spc="300" dirty="0">
                 <a:solidFill>
                   <a:srgbClr val="64748B"/>
                 </a:solidFill>
@@ -8659,11 +8508,11 @@
           <a:bodyPr wrap="square" rtlCol="0" anchor="ctr"/>
           <a:lstStyle/>
           <a:p>
-            <a:pPr indent="0" marL="0">
-              <a:buNone/>
-            </a:pPr>
-            <a:r>
-              <a:rPr lang="en-US" sz="1100" b="1" spc="200" kern="0" dirty="0">
+            <a:pPr marL="0" indent="0">
+              <a:buNone/>
+            </a:pPr>
+            <a:r>
+              <a:rPr lang="en-US" sz="1100" b="1" kern="0" spc="200" dirty="0">
                 <a:solidFill>
                   <a:srgbClr val="F1F5F9"/>
                 </a:solidFill>
@@ -8698,7 +8547,7 @@
           <a:bodyPr wrap="square" rtlCol="0" anchor="ctr"/>
           <a:lstStyle/>
           <a:p>
-            <a:pPr algn="r" indent="0" marL="0">
+            <a:pPr marL="0" indent="0" algn="r">
               <a:buNone/>
             </a:pPr>
             <a:r>
@@ -8757,11 +8606,11 @@
           <a:bodyPr wrap="square" rtlCol="0" anchor="ctr"/>
           <a:lstStyle/>
           <a:p>
-            <a:pPr indent="0" marL="0">
-              <a:buNone/>
-            </a:pPr>
-            <a:r>
-              <a:rPr lang="en-US" sz="1100" b="1" spc="200" kern="0" dirty="0">
+            <a:pPr marL="0" indent="0">
+              <a:buNone/>
+            </a:pPr>
+            <a:r>
+              <a:rPr lang="en-US" sz="1100" b="1" kern="0" spc="200" dirty="0">
                 <a:solidFill>
                   <a:srgbClr val="F1F5F9"/>
                 </a:solidFill>
@@ -8796,7 +8645,7 @@
           <a:bodyPr wrap="square" rtlCol="0" anchor="ctr"/>
           <a:lstStyle/>
           <a:p>
-            <a:pPr algn="r" indent="0" marL="0">
+            <a:pPr marL="0" indent="0" algn="r">
               <a:buNone/>
             </a:pPr>
             <a:r>
@@ -8855,11 +8704,11 @@
           <a:bodyPr wrap="square" rtlCol="0" anchor="ctr"/>
           <a:lstStyle/>
           <a:p>
-            <a:pPr indent="0" marL="0">
-              <a:buNone/>
-            </a:pPr>
-            <a:r>
-              <a:rPr lang="en-US" sz="1100" b="1" spc="200" kern="0" dirty="0">
+            <a:pPr marL="0" indent="0">
+              <a:buNone/>
+            </a:pPr>
+            <a:r>
+              <a:rPr lang="en-US" sz="1100" b="1" kern="0" spc="200" dirty="0">
                 <a:solidFill>
                   <a:srgbClr val="F1F5F9"/>
                 </a:solidFill>
@@ -8894,7 +8743,7 @@
           <a:bodyPr wrap="square" rtlCol="0" anchor="ctr"/>
           <a:lstStyle/>
           <a:p>
-            <a:pPr algn="r" indent="0" marL="0">
+            <a:pPr marL="0" indent="0" algn="r">
               <a:buNone/>
             </a:pPr>
             <a:r>
@@ -8917,6 +8766,18 @@
   <p:clrMapOvr>
     <a:masterClrMapping/>
   </p:clrMapOvr>
+  <mc:AlternateContent xmlns:mc="http://schemas.openxmlformats.org/markup-compatibility/2006">
+    <mc:Choice xmlns:p159="http://schemas.microsoft.com/office/powerpoint/2015/09/main" Requires="p159">
+      <p:transition xmlns:p14="http://schemas.microsoft.com/office/powerpoint/2010/main" spd="slow" p14:dur="2000">
+        <p159:morph option="byObject"/>
+      </p:transition>
+    </mc:Choice>
+    <mc:Fallback>
+      <p:transition spd="slow">
+        <p:fade/>
+      </p:transition>
+    </mc:Fallback>
+  </mc:AlternateContent>
 </p:sld>
 </file>
 
@@ -8928,6 +8789,7 @@
         <a:solidFill>
           <a:srgbClr val="0B1120"/>
         </a:solidFill>
+        <a:effectLst/>
       </p:bgPr>
     </p:bg>
     <p:spTree>
@@ -8965,11 +8827,11 @@
           <a:bodyPr wrap="square" rtlCol="0" anchor="ctr"/>
           <a:lstStyle/>
           <a:p>
-            <a:pPr indent="0" marL="0">
-              <a:buNone/>
-            </a:pPr>
-            <a:r>
-              <a:rPr lang="en-US" sz="900" b="1" spc="500" kern="0" dirty="0">
+            <a:pPr marL="0" indent="0">
+              <a:buNone/>
+            </a:pPr>
+            <a:r>
+              <a:rPr lang="en-US" sz="900" b="1" kern="0" spc="500" dirty="0">
                 <a:solidFill>
                   <a:srgbClr val="F97316"/>
                 </a:solidFill>
@@ -9004,11 +8866,11 @@
           <a:bodyPr wrap="square" rtlCol="0" anchor="ctr"/>
           <a:lstStyle/>
           <a:p>
-            <a:pPr indent="0" marL="0">
-              <a:buNone/>
-            </a:pPr>
-            <a:r>
-              <a:rPr lang="en-US" sz="900" spc="400" kern="0" dirty="0">
+            <a:pPr marL="0" indent="0">
+              <a:buNone/>
+            </a:pPr>
+            <a:r>
+              <a:rPr lang="en-US" sz="900" kern="0" spc="400" dirty="0">
                 <a:solidFill>
                   <a:srgbClr val="64748B"/>
                 </a:solidFill>
@@ -9043,7 +8905,7 @@
           <a:bodyPr wrap="square" rtlCol="0" anchor="ctr"/>
           <a:lstStyle/>
           <a:p>
-            <a:pPr algn="r" indent="0" marL="0">
+            <a:pPr marL="0" indent="0" algn="r">
               <a:buNone/>
             </a:pPr>
             <a:r>
@@ -9128,7 +8990,7 @@
           <a:bodyPr wrap="square" rtlCol="0" anchor="ctr"/>
           <a:lstStyle/>
           <a:p>
-            <a:pPr indent="0" marL="0">
+            <a:pPr marL="0" indent="0">
               <a:buNone/>
             </a:pPr>
             <a:r>
@@ -9167,7 +9029,7 @@
           <a:bodyPr wrap="square" rtlCol="0" anchor="ctr"/>
           <a:lstStyle/>
           <a:p>
-            <a:pPr algn="r" indent="0" marL="0">
+            <a:pPr marL="0" indent="0" algn="r">
               <a:buNone/>
             </a:pPr>
             <a:r>
@@ -9206,11 +9068,11 @@
           <a:bodyPr wrap="square" rtlCol="0" anchor="ctr"/>
           <a:lstStyle/>
           <a:p>
-            <a:pPr indent="0" marL="0">
-              <a:buNone/>
-            </a:pPr>
-            <a:r>
-              <a:rPr lang="en-US" sz="3000" b="1" spc="-50" kern="0" dirty="0">
+            <a:pPr marL="0" indent="0">
+              <a:buNone/>
+            </a:pPr>
+            <a:r>
+              <a:rPr lang="en-US" sz="3000" b="1" kern="0" spc="-50" dirty="0">
                 <a:solidFill>
                   <a:srgbClr val="F1F5F9"/>
                 </a:solidFill>
@@ -9245,7 +9107,7 @@
           <a:bodyPr wrap="square" rtlCol="0" anchor="ctr"/>
           <a:lstStyle/>
           <a:p>
-            <a:pPr indent="0" marL="0">
+            <a:pPr marL="0" indent="0">
               <a:buNone/>
             </a:pPr>
             <a:r>
@@ -9331,7 +9193,7 @@
           <a:bodyPr wrap="square" rtlCol="0" anchor="ctr"/>
           <a:lstStyle/>
           <a:p>
-            <a:pPr algn="ctr" indent="0" marL="0">
+            <a:pPr marL="0" indent="0" algn="ctr">
               <a:buNone/>
             </a:pPr>
             <a:r>
@@ -9393,7 +9255,7 @@
           <a:bodyPr wrap="square" rtlCol="0" anchor="ctr"/>
           <a:lstStyle/>
           <a:p>
-            <a:pPr algn="ctr" indent="0" marL="0">
+            <a:pPr marL="0" indent="0" algn="ctr">
               <a:buNone/>
             </a:pPr>
             <a:r>
@@ -9410,7 +9272,7 @@
             <a:endParaRPr lang="en-US" sz="1300" dirty="0"/>
           </a:p>
           <a:p>
-            <a:pPr algn="ctr" indent="0" marL="0">
+            <a:pPr marL="0" indent="0" algn="ctr">
               <a:buNone/>
             </a:pPr>
             <a:r>
@@ -9478,7 +9340,7 @@
           <a:bodyPr wrap="square" rtlCol="0" anchor="ctr"/>
           <a:lstStyle/>
           <a:p>
-            <a:pPr algn="ctr" indent="0" marL="0">
+            <a:pPr marL="0" indent="0" algn="ctr">
               <a:buNone/>
             </a:pPr>
             <a:r>
@@ -9564,7 +9426,7 @@
           <a:bodyPr wrap="square" rtlCol="0" anchor="ctr"/>
           <a:lstStyle/>
           <a:p>
-            <a:pPr algn="ctr" indent="0" marL="0">
+            <a:pPr marL="0" indent="0" algn="ctr">
               <a:buNone/>
             </a:pPr>
             <a:r>
@@ -9626,7 +9488,7 @@
           <a:bodyPr wrap="square" rtlCol="0" anchor="ctr"/>
           <a:lstStyle/>
           <a:p>
-            <a:pPr algn="ctr" indent="0" marL="0">
+            <a:pPr marL="0" indent="0" algn="ctr">
               <a:buNone/>
             </a:pPr>
             <a:r>
@@ -9643,7 +9505,7 @@
             <a:endParaRPr lang="en-US" sz="1300" dirty="0"/>
           </a:p>
           <a:p>
-            <a:pPr algn="ctr" indent="0" marL="0">
+            <a:pPr marL="0" indent="0" algn="ctr">
               <a:buNone/>
             </a:pPr>
             <a:r>
@@ -9711,7 +9573,7 @@
           <a:bodyPr wrap="square" rtlCol="0" anchor="ctr"/>
           <a:lstStyle/>
           <a:p>
-            <a:pPr algn="ctr" indent="0" marL="0">
+            <a:pPr marL="0" indent="0" algn="ctr">
               <a:buNone/>
             </a:pPr>
             <a:r>
@@ -9797,7 +9659,7 @@
           <a:bodyPr wrap="square" rtlCol="0" anchor="ctr"/>
           <a:lstStyle/>
           <a:p>
-            <a:pPr algn="ctr" indent="0" marL="0">
+            <a:pPr marL="0" indent="0" algn="ctr">
               <a:buNone/>
             </a:pPr>
             <a:r>
@@ -9859,7 +9721,7 @@
           <a:bodyPr wrap="square" rtlCol="0" anchor="ctr"/>
           <a:lstStyle/>
           <a:p>
-            <a:pPr algn="ctr" indent="0" marL="0">
+            <a:pPr marL="0" indent="0" algn="ctr">
               <a:buNone/>
             </a:pPr>
             <a:r>
@@ -9876,7 +9738,7 @@
             <a:endParaRPr lang="en-US" sz="1300" dirty="0"/>
           </a:p>
           <a:p>
-            <a:pPr algn="ctr" indent="0" marL="0">
+            <a:pPr marL="0" indent="0" algn="ctr">
               <a:buNone/>
             </a:pPr>
             <a:r>
@@ -9944,7 +9806,7 @@
           <a:bodyPr wrap="square" rtlCol="0" anchor="ctr"/>
           <a:lstStyle/>
           <a:p>
-            <a:pPr algn="ctr" indent="0" marL="0">
+            <a:pPr marL="0" indent="0" algn="ctr">
               <a:buNone/>
             </a:pPr>
             <a:r>
@@ -9967,6 +9829,18 @@
   <p:clrMapOvr>
     <a:masterClrMapping/>
   </p:clrMapOvr>
+  <mc:AlternateContent xmlns:mc="http://schemas.openxmlformats.org/markup-compatibility/2006">
+    <mc:Choice xmlns:p159="http://schemas.microsoft.com/office/powerpoint/2015/09/main" Requires="p159">
+      <p:transition xmlns:p14="http://schemas.microsoft.com/office/powerpoint/2010/main" spd="slow" p14:dur="2000">
+        <p159:morph option="byObject"/>
+      </p:transition>
+    </mc:Choice>
+    <mc:Fallback>
+      <p:transition spd="slow">
+        <p:fade/>
+      </p:transition>
+    </mc:Fallback>
+  </mc:AlternateContent>
 </p:sld>
 </file>
 
@@ -9978,6 +9852,7 @@
         <a:solidFill>
           <a:srgbClr val="0B1120"/>
         </a:solidFill>
+        <a:effectLst/>
       </p:bgPr>
     </p:bg>
     <p:spTree>
@@ -10015,11 +9890,11 @@
           <a:bodyPr wrap="square" rtlCol="0" anchor="ctr"/>
           <a:lstStyle/>
           <a:p>
-            <a:pPr indent="0" marL="0">
-              <a:buNone/>
-            </a:pPr>
-            <a:r>
-              <a:rPr lang="en-US" sz="900" b="1" spc="500" kern="0" dirty="0">
+            <a:pPr marL="0" indent="0">
+              <a:buNone/>
+            </a:pPr>
+            <a:r>
+              <a:rPr lang="en-US" sz="900" b="1" kern="0" spc="500" dirty="0">
                 <a:solidFill>
                   <a:srgbClr val="F97316"/>
                 </a:solidFill>
@@ -10054,11 +9929,11 @@
           <a:bodyPr wrap="square" rtlCol="0" anchor="ctr"/>
           <a:lstStyle/>
           <a:p>
-            <a:pPr indent="0" marL="0">
-              <a:buNone/>
-            </a:pPr>
-            <a:r>
-              <a:rPr lang="en-US" sz="900" spc="400" kern="0" dirty="0">
+            <a:pPr marL="0" indent="0">
+              <a:buNone/>
+            </a:pPr>
+            <a:r>
+              <a:rPr lang="en-US" sz="900" kern="0" spc="400" dirty="0">
                 <a:solidFill>
                   <a:srgbClr val="64748B"/>
                 </a:solidFill>
@@ -10093,7 +9968,7 @@
           <a:bodyPr wrap="square" rtlCol="0" anchor="ctr"/>
           <a:lstStyle/>
           <a:p>
-            <a:pPr algn="r" indent="0" marL="0">
+            <a:pPr marL="0" indent="0" algn="r">
               <a:buNone/>
             </a:pPr>
             <a:r>
@@ -10178,7 +10053,7 @@
           <a:bodyPr wrap="square" rtlCol="0" anchor="ctr"/>
           <a:lstStyle/>
           <a:p>
-            <a:pPr indent="0" marL="0">
+            <a:pPr marL="0" indent="0">
               <a:buNone/>
             </a:pPr>
             <a:r>
@@ -10217,7 +10092,7 @@
           <a:bodyPr wrap="square" rtlCol="0" anchor="ctr"/>
           <a:lstStyle/>
           <a:p>
-            <a:pPr algn="r" indent="0" marL="0">
+            <a:pPr marL="0" indent="0" algn="r">
               <a:buNone/>
             </a:pPr>
             <a:r>
@@ -10256,11 +10131,11 @@
           <a:bodyPr wrap="square" rtlCol="0" anchor="ctr"/>
           <a:lstStyle/>
           <a:p>
-            <a:pPr indent="0" marL="0">
-              <a:buNone/>
-            </a:pPr>
-            <a:r>
-              <a:rPr lang="en-US" sz="3000" b="1" spc="-50" kern="0" dirty="0">
+            <a:pPr marL="0" indent="0">
+              <a:buNone/>
+            </a:pPr>
+            <a:r>
+              <a:rPr lang="en-US" sz="3000" b="1" kern="0" spc="-50" dirty="0">
                 <a:solidFill>
                   <a:srgbClr val="F1F5F9"/>
                 </a:solidFill>
@@ -10295,7 +10170,7 @@
           <a:bodyPr wrap="square" rtlCol="0" anchor="ctr"/>
           <a:lstStyle/>
           <a:p>
-            <a:pPr indent="0" marL="0">
+            <a:pPr marL="0" indent="0">
               <a:buNone/>
             </a:pPr>
             <a:r>
@@ -10361,11 +10236,11 @@
           <a:bodyPr wrap="square" rtlCol="0" anchor="ctr"/>
           <a:lstStyle/>
           <a:p>
-            <a:pPr indent="0" marL="0">
-              <a:buNone/>
-            </a:pPr>
-            <a:r>
-              <a:rPr lang="en-US" sz="900" b="1" spc="300" kern="0" dirty="0">
+            <a:pPr marL="0" indent="0">
+              <a:buNone/>
+            </a:pPr>
+            <a:r>
+              <a:rPr lang="en-US" sz="900" b="1" kern="0" spc="300" dirty="0">
                 <a:solidFill>
                   <a:srgbClr val="F97316"/>
                 </a:solidFill>
@@ -10400,7 +10275,7 @@
           <a:bodyPr wrap="square" rtlCol="0" anchor="ctr"/>
           <a:lstStyle/>
           <a:p>
-            <a:pPr indent="0" marL="0">
+            <a:pPr marL="0" indent="0">
               <a:buNone/>
             </a:pPr>
             <a:r>
@@ -10482,7 +10357,7 @@
           <a:bodyPr wrap="square" rtlCol="0" anchor="ctr"/>
           <a:lstStyle/>
           <a:p>
-            <a:pPr indent="0" marL="0">
+            <a:pPr marL="0" indent="0">
               <a:buNone/>
             </a:pPr>
             <a:r>
@@ -10521,7 +10396,7 @@
           <a:bodyPr wrap="square" rtlCol="0" anchor="t"/>
           <a:lstStyle/>
           <a:p>
-            <a:pPr indent="0" marL="0">
+            <a:pPr marL="0" indent="0">
               <a:buNone/>
             </a:pPr>
             <a:r>
@@ -10580,7 +10455,7 @@
           <a:bodyPr wrap="square" rtlCol="0" anchor="ctr"/>
           <a:lstStyle/>
           <a:p>
-            <a:pPr indent="0" marL="0">
+            <a:pPr marL="0" indent="0">
               <a:buNone/>
             </a:pPr>
             <a:r>
@@ -10619,7 +10494,7 @@
           <a:bodyPr wrap="square" rtlCol="0" anchor="t"/>
           <a:lstStyle/>
           <a:p>
-            <a:pPr indent="0" marL="0">
+            <a:pPr marL="0" indent="0">
               <a:buNone/>
             </a:pPr>
             <a:r>
@@ -10678,7 +10553,7 @@
           <a:bodyPr wrap="square" rtlCol="0" anchor="ctr"/>
           <a:lstStyle/>
           <a:p>
-            <a:pPr indent="0" marL="0">
+            <a:pPr marL="0" indent="0">
               <a:buNone/>
             </a:pPr>
             <a:r>
@@ -10717,7 +10592,7 @@
           <a:bodyPr wrap="square" rtlCol="0" anchor="t"/>
           <a:lstStyle/>
           <a:p>
-            <a:pPr indent="0" marL="0">
+            <a:pPr marL="0" indent="0">
               <a:buNone/>
             </a:pPr>
             <a:r>
@@ -10783,11 +10658,11 @@
           <a:bodyPr wrap="square" rtlCol="0" anchor="ctr"/>
           <a:lstStyle/>
           <a:p>
-            <a:pPr indent="0" marL="0">
-              <a:buNone/>
-            </a:pPr>
-            <a:r>
-              <a:rPr lang="en-US" sz="900" b="1" spc="300" kern="0" dirty="0">
+            <a:pPr marL="0" indent="0">
+              <a:buNone/>
+            </a:pPr>
+            <a:r>
+              <a:rPr lang="en-US" sz="900" b="1" kern="0" spc="300" dirty="0">
                 <a:solidFill>
                   <a:srgbClr val="38BDF8"/>
                 </a:solidFill>
@@ -10822,7 +10697,7 @@
           <a:bodyPr wrap="square" rtlCol="0" anchor="ctr"/>
           <a:lstStyle/>
           <a:p>
-            <a:pPr indent="0" marL="0">
+            <a:pPr marL="0" indent="0">
               <a:buNone/>
             </a:pPr>
             <a:r>
@@ -10884,7 +10759,7 @@
           <a:bodyPr wrap="square" rtlCol="0" anchor="ctr"/>
           <a:lstStyle/>
           <a:p>
-            <a:pPr indent="0" marL="0">
+            <a:pPr marL="0" indent="0">
               <a:buNone/>
             </a:pPr>
             <a:r>
@@ -10923,7 +10798,7 @@
           <a:bodyPr wrap="square" rtlCol="0" anchor="ctr"/>
           <a:lstStyle/>
           <a:p>
-            <a:pPr indent="0" marL="0">
+            <a:pPr marL="0" indent="0">
               <a:buNone/>
             </a:pPr>
             <a:r>
@@ -10962,7 +10837,7 @@
           <a:bodyPr wrap="square" rtlCol="0" anchor="ctr"/>
           <a:lstStyle/>
           <a:p>
-            <a:pPr algn="r" indent="0" marL="0">
+            <a:pPr marL="0" indent="0" algn="r">
               <a:buNone/>
             </a:pPr>
             <a:r>
@@ -11001,7 +10876,7 @@
           <a:bodyPr wrap="square" rtlCol="0" anchor="ctr"/>
           <a:lstStyle/>
           <a:p>
-            <a:pPr indent="0" marL="0">
+            <a:pPr marL="0" indent="0">
               <a:buNone/>
             </a:pPr>
             <a:r>
@@ -11080,7 +10955,7 @@
           <a:bodyPr wrap="square" rtlCol="0" anchor="ctr"/>
           <a:lstStyle/>
           <a:p>
-            <a:pPr indent="0" marL="0">
+            <a:pPr marL="0" indent="0">
               <a:buNone/>
             </a:pPr>
             <a:r>
@@ -11119,7 +10994,7 @@
           <a:bodyPr wrap="square" rtlCol="0" anchor="ctr"/>
           <a:lstStyle/>
           <a:p>
-            <a:pPr indent="0" marL="0">
+            <a:pPr marL="0" indent="0">
               <a:buNone/>
             </a:pPr>
             <a:r>
@@ -11158,7 +11033,7 @@
           <a:bodyPr wrap="square" rtlCol="0" anchor="ctr"/>
           <a:lstStyle/>
           <a:p>
-            <a:pPr algn="r" indent="0" marL="0">
+            <a:pPr marL="0" indent="0" algn="r">
               <a:buNone/>
             </a:pPr>
             <a:r>
@@ -11197,7 +11072,7 @@
           <a:bodyPr wrap="square" rtlCol="0" anchor="ctr"/>
           <a:lstStyle/>
           <a:p>
-            <a:pPr indent="0" marL="0">
+            <a:pPr marL="0" indent="0">
               <a:buNone/>
             </a:pPr>
             <a:r>
@@ -11276,7 +11151,7 @@
           <a:bodyPr wrap="square" rtlCol="0" anchor="ctr"/>
           <a:lstStyle/>
           <a:p>
-            <a:pPr indent="0" marL="0">
+            <a:pPr marL="0" indent="0">
               <a:buNone/>
             </a:pPr>
             <a:r>
@@ -11315,7 +11190,7 @@
           <a:bodyPr wrap="square" rtlCol="0" anchor="ctr"/>
           <a:lstStyle/>
           <a:p>
-            <a:pPr indent="0" marL="0">
+            <a:pPr marL="0" indent="0">
               <a:buNone/>
             </a:pPr>
             <a:r>
@@ -11354,7 +11229,7 @@
           <a:bodyPr wrap="square" rtlCol="0" anchor="ctr"/>
           <a:lstStyle/>
           <a:p>
-            <a:pPr algn="r" indent="0" marL="0">
+            <a:pPr marL="0" indent="0" algn="r">
               <a:buNone/>
             </a:pPr>
             <a:r>
@@ -11393,7 +11268,7 @@
           <a:bodyPr wrap="square" rtlCol="0" anchor="ctr"/>
           <a:lstStyle/>
           <a:p>
-            <a:pPr indent="0" marL="0">
+            <a:pPr marL="0" indent="0">
               <a:buNone/>
             </a:pPr>
             <a:r>
@@ -11456,6 +11331,18 @@
   <p:clrMapOvr>
     <a:masterClrMapping/>
   </p:clrMapOvr>
+  <mc:AlternateContent xmlns:mc="http://schemas.openxmlformats.org/markup-compatibility/2006">
+    <mc:Choice xmlns:p159="http://schemas.microsoft.com/office/powerpoint/2015/09/main" Requires="p159">
+      <p:transition xmlns:p14="http://schemas.microsoft.com/office/powerpoint/2010/main" spd="slow" p14:dur="2000">
+        <p159:morph option="byObject"/>
+      </p:transition>
+    </mc:Choice>
+    <mc:Fallback>
+      <p:transition spd="slow">
+        <p:fade/>
+      </p:transition>
+    </mc:Fallback>
+  </mc:AlternateContent>
 </p:sld>
 </file>
 
@@ -11467,6 +11354,7 @@
         <a:solidFill>
           <a:srgbClr val="0B1120"/>
         </a:solidFill>
+        <a:effectLst/>
       </p:bgPr>
     </p:bg>
     <p:spTree>
@@ -11504,11 +11392,11 @@
           <a:bodyPr wrap="square" rtlCol="0" anchor="ctr"/>
           <a:lstStyle/>
           <a:p>
-            <a:pPr indent="0" marL="0">
-              <a:buNone/>
-            </a:pPr>
-            <a:r>
-              <a:rPr lang="en-US" sz="900" b="1" spc="500" kern="0" dirty="0">
+            <a:pPr marL="0" indent="0">
+              <a:buNone/>
+            </a:pPr>
+            <a:r>
+              <a:rPr lang="en-US" sz="900" b="1" kern="0" spc="500" dirty="0">
                 <a:solidFill>
                   <a:srgbClr val="F97316"/>
                 </a:solidFill>
@@ -11543,11 +11431,11 @@
           <a:bodyPr wrap="square" rtlCol="0" anchor="ctr"/>
           <a:lstStyle/>
           <a:p>
-            <a:pPr indent="0" marL="0">
-              <a:buNone/>
-            </a:pPr>
-            <a:r>
-              <a:rPr lang="en-US" sz="900" spc="400" kern="0" dirty="0">
+            <a:pPr marL="0" indent="0">
+              <a:buNone/>
+            </a:pPr>
+            <a:r>
+              <a:rPr lang="en-US" sz="900" kern="0" spc="400" dirty="0">
                 <a:solidFill>
                   <a:srgbClr val="64748B"/>
                 </a:solidFill>
@@ -11582,7 +11470,7 @@
           <a:bodyPr wrap="square" rtlCol="0" anchor="ctr"/>
           <a:lstStyle/>
           <a:p>
-            <a:pPr algn="r" indent="0" marL="0">
+            <a:pPr marL="0" indent="0" algn="r">
               <a:buNone/>
             </a:pPr>
             <a:r>
@@ -11667,7 +11555,7 @@
           <a:bodyPr wrap="square" rtlCol="0" anchor="ctr"/>
           <a:lstStyle/>
           <a:p>
-            <a:pPr indent="0" marL="0">
+            <a:pPr marL="0" indent="0">
               <a:buNone/>
             </a:pPr>
             <a:r>
@@ -11706,7 +11594,7 @@
           <a:bodyPr wrap="square" rtlCol="0" anchor="ctr"/>
           <a:lstStyle/>
           <a:p>
-            <a:pPr algn="r" indent="0" marL="0">
+            <a:pPr marL="0" indent="0" algn="r">
               <a:buNone/>
             </a:pPr>
             <a:r>
@@ -11745,11 +11633,11 @@
           <a:bodyPr wrap="square" rtlCol="0" anchor="ctr"/>
           <a:lstStyle/>
           <a:p>
-            <a:pPr indent="0" marL="0">
-              <a:buNone/>
-            </a:pPr>
-            <a:r>
-              <a:rPr lang="en-US" sz="3000" b="1" spc="-50" kern="0" dirty="0">
+            <a:pPr marL="0" indent="0">
+              <a:buNone/>
+            </a:pPr>
+            <a:r>
+              <a:rPr lang="en-US" sz="3000" b="1" kern="0" spc="-50" dirty="0">
                 <a:solidFill>
                   <a:srgbClr val="F1F5F9"/>
                 </a:solidFill>
@@ -11784,7 +11672,7 @@
           <a:bodyPr wrap="square" rtlCol="0" anchor="ctr"/>
           <a:lstStyle/>
           <a:p>
-            <a:pPr indent="0" marL="0">
+            <a:pPr marL="0" indent="0">
               <a:buNone/>
             </a:pPr>
             <a:r>
@@ -11870,7 +11758,7 @@
           <a:bodyPr wrap="square" rtlCol="0" anchor="ctr"/>
           <a:lstStyle/>
           <a:p>
-            <a:pPr indent="0" marL="0">
+            <a:pPr marL="0" indent="0">
               <a:buNone/>
             </a:pPr>
             <a:r>
@@ -11909,7 +11797,7 @@
           <a:bodyPr wrap="square" rtlCol="0" anchor="ctr"/>
           <a:lstStyle/>
           <a:p>
-            <a:pPr indent="0" marL="0">
+            <a:pPr marL="0" indent="0">
               <a:buNone/>
             </a:pPr>
             <a:r>
@@ -11995,7 +11883,7 @@
           <a:bodyPr wrap="square" rtlCol="0" anchor="ctr"/>
           <a:lstStyle/>
           <a:p>
-            <a:pPr indent="0" marL="0">
+            <a:pPr marL="0" indent="0">
               <a:buNone/>
             </a:pPr>
             <a:r>
@@ -12034,7 +11922,7 @@
           <a:bodyPr wrap="square" rtlCol="0" anchor="ctr"/>
           <a:lstStyle/>
           <a:p>
-            <a:pPr indent="0" marL="0">
+            <a:pPr marL="0" indent="0">
               <a:buNone/>
             </a:pPr>
             <a:r>
@@ -12120,7 +12008,7 @@
           <a:bodyPr wrap="square" rtlCol="0" anchor="ctr"/>
           <a:lstStyle/>
           <a:p>
-            <a:pPr indent="0" marL="0">
+            <a:pPr marL="0" indent="0">
               <a:buNone/>
             </a:pPr>
             <a:r>
@@ -12159,7 +12047,7 @@
           <a:bodyPr wrap="square" rtlCol="0" anchor="ctr"/>
           <a:lstStyle/>
           <a:p>
-            <a:pPr indent="0" marL="0">
+            <a:pPr marL="0" indent="0">
               <a:buNone/>
             </a:pPr>
             <a:r>
@@ -12245,7 +12133,7 @@
           <a:bodyPr wrap="square" rtlCol="0" anchor="ctr"/>
           <a:lstStyle/>
           <a:p>
-            <a:pPr indent="0" marL="0">
+            <a:pPr marL="0" indent="0">
               <a:buNone/>
             </a:pPr>
             <a:r>
@@ -12284,7 +12172,7 @@
           <a:bodyPr wrap="square" rtlCol="0" anchor="ctr"/>
           <a:lstStyle/>
           <a:p>
-            <a:pPr indent="0" marL="0">
+            <a:pPr marL="0" indent="0">
               <a:buNone/>
             </a:pPr>
             <a:r>
@@ -12350,11 +12238,11 @@
           <a:bodyPr wrap="square" rtlCol="0" anchor="ctr"/>
           <a:lstStyle/>
           <a:p>
-            <a:pPr indent="0" marL="0">
-              <a:buNone/>
-            </a:pPr>
-            <a:r>
-              <a:rPr lang="en-US" sz="900" b="1" spc="300" kern="0" dirty="0">
+            <a:pPr marL="0" indent="0">
+              <a:buNone/>
+            </a:pPr>
+            <a:r>
+              <a:rPr lang="en-US" sz="900" b="1" kern="0" spc="300" dirty="0">
                 <a:solidFill>
                   <a:srgbClr val="F97316"/>
                 </a:solidFill>
@@ -12389,11 +12277,11 @@
           <a:bodyPr wrap="square" rtlCol="0" anchor="ctr"/>
           <a:lstStyle/>
           <a:p>
-            <a:pPr indent="0" marL="0">
-              <a:buNone/>
-            </a:pPr>
-            <a:r>
-              <a:rPr lang="en-US" sz="2800" b="1" spc="-100" kern="0" dirty="0">
+            <a:pPr marL="0" indent="0">
+              <a:buNone/>
+            </a:pPr>
+            <a:r>
+              <a:rPr lang="en-US" sz="2800" b="1" kern="0" spc="-100" dirty="0">
                 <a:solidFill>
                   <a:srgbClr val="F1F5F9"/>
                 </a:solidFill>
@@ -12406,11 +12294,11 @@
             <a:endParaRPr lang="en-US" sz="2800" dirty="0"/>
           </a:p>
           <a:p>
-            <a:pPr indent="0" marL="0">
-              <a:buNone/>
-            </a:pPr>
-            <a:r>
-              <a:rPr lang="en-US" sz="2800" b="1" spc="-100" kern="0" dirty="0">
+            <a:pPr marL="0" indent="0">
+              <a:buNone/>
+            </a:pPr>
+            <a:r>
+              <a:rPr lang="en-US" sz="2800" b="1" kern="0" spc="-100" dirty="0">
                 <a:solidFill>
                   <a:srgbClr val="F1F5F9"/>
                 </a:solidFill>
@@ -12488,7 +12376,7 @@
           <a:bodyPr wrap="square" rtlCol="0" anchor="ctr"/>
           <a:lstStyle/>
           <a:p>
-            <a:pPr indent="0" marL="0">
+            <a:pPr marL="0" indent="0">
               <a:buNone/>
             </a:pPr>
             <a:r>
@@ -12547,7 +12435,7 @@
           <a:bodyPr wrap="square" rtlCol="0" anchor="ctr"/>
           <a:lstStyle/>
           <a:p>
-            <a:pPr indent="0" marL="0">
+            <a:pPr marL="0" indent="0">
               <a:buNone/>
             </a:pPr>
             <a:r>
@@ -12606,7 +12494,7 @@
           <a:bodyPr wrap="square" rtlCol="0" anchor="ctr"/>
           <a:lstStyle/>
           <a:p>
-            <a:pPr indent="0" marL="0">
+            <a:pPr marL="0" indent="0">
               <a:buNone/>
             </a:pPr>
             <a:r>
@@ -12665,7 +12553,7 @@
           <a:bodyPr wrap="square" rtlCol="0" anchor="ctr"/>
           <a:lstStyle/>
           <a:p>
-            <a:pPr indent="0" marL="0">
+            <a:pPr marL="0" indent="0">
               <a:buNone/>
             </a:pPr>
             <a:r>
@@ -12688,6 +12576,18 @@
   <p:clrMapOvr>
     <a:masterClrMapping/>
   </p:clrMapOvr>
+  <mc:AlternateContent xmlns:mc="http://schemas.openxmlformats.org/markup-compatibility/2006">
+    <mc:Choice xmlns:p159="http://schemas.microsoft.com/office/powerpoint/2015/09/main" Requires="p159">
+      <p:transition xmlns:p14="http://schemas.microsoft.com/office/powerpoint/2010/main" spd="slow" p14:dur="2000">
+        <p159:morph option="byObject"/>
+      </p:transition>
+    </mc:Choice>
+    <mc:Fallback>
+      <p:transition spd="slow">
+        <p:fade/>
+      </p:transition>
+    </mc:Fallback>
+  </mc:AlternateContent>
 </p:sld>
 </file>
 
@@ -12984,4 +12884,319 @@
     </a:ext>
   </a:extLst>
 </a:theme>
+</file>
+
+<file path=ppt/theme/theme2.xml><?xml version="1.0" encoding="utf-8"?>
+<a:theme xmlns:a="http://schemas.openxmlformats.org/drawingml/2006/main" name="Office Theme">
+  <a:themeElements>
+    <a:clrScheme name="Office">
+      <a:dk1>
+        <a:sysClr val="windowText" lastClr="000000"/>
+      </a:dk1>
+      <a:lt1>
+        <a:sysClr val="window" lastClr="FFFFFF"/>
+      </a:lt1>
+      <a:dk2>
+        <a:srgbClr val="0E2841"/>
+      </a:dk2>
+      <a:lt2>
+        <a:srgbClr val="E8E8E8"/>
+      </a:lt2>
+      <a:accent1>
+        <a:srgbClr val="156082"/>
+      </a:accent1>
+      <a:accent2>
+        <a:srgbClr val="E97132"/>
+      </a:accent2>
+      <a:accent3>
+        <a:srgbClr val="196B24"/>
+      </a:accent3>
+      <a:accent4>
+        <a:srgbClr val="0F9ED5"/>
+      </a:accent4>
+      <a:accent5>
+        <a:srgbClr val="A02B93"/>
+      </a:accent5>
+      <a:accent6>
+        <a:srgbClr val="4EA72E"/>
+      </a:accent6>
+      <a:hlink>
+        <a:srgbClr val="467886"/>
+      </a:hlink>
+      <a:folHlink>
+        <a:srgbClr val="96607D"/>
+      </a:folHlink>
+    </a:clrScheme>
+    <a:fontScheme name="Office">
+      <a:majorFont>
+        <a:latin typeface="Aptos Display" panose="02110004020202020204"/>
+        <a:ea typeface=""/>
+        <a:cs typeface=""/>
+        <a:font script="Jpan" typeface="游ゴシック Light"/>
+        <a:font script="Hang" typeface="맑은 고딕"/>
+        <a:font script="Hans" typeface="等线 Light"/>
+        <a:font script="Hant" typeface="新細明體"/>
+        <a:font script="Arab" typeface="Times New Roman"/>
+        <a:font script="Hebr" typeface="Times New Roman"/>
+        <a:font script="Thai" typeface="Angsana New"/>
+        <a:font script="Ethi" typeface="Nyala"/>
+        <a:font script="Beng" typeface="Vrinda"/>
+        <a:font script="Gujr" typeface="Shruti"/>
+        <a:font script="Khmr" typeface="MoolBoran"/>
+        <a:font script="Knda" typeface="Tunga"/>
+        <a:font script="Guru" typeface="Raavi"/>
+        <a:font script="Cans" typeface="Euphemia"/>
+        <a:font script="Cher" typeface="Plantagenet Cherokee"/>
+        <a:font script="Yiii" typeface="Microsoft Yi Baiti"/>
+        <a:font script="Tibt" typeface="Microsoft Himalaya"/>
+        <a:font script="Thaa" typeface="MV Boli"/>
+        <a:font script="Deva" typeface="Mangal"/>
+        <a:font script="Telu" typeface="Gautami"/>
+        <a:font script="Taml" typeface="Latha"/>
+        <a:font script="Syrc" typeface="Estrangelo Edessa"/>
+        <a:font script="Orya" typeface="Kalinga"/>
+        <a:font script="Mlym" typeface="Kartika"/>
+        <a:font script="Laoo" typeface="DokChampa"/>
+        <a:font script="Sinh" typeface="Iskoola Pota"/>
+        <a:font script="Mong" typeface="Mongolian Baiti"/>
+        <a:font script="Viet" typeface="Times New Roman"/>
+        <a:font script="Uigh" typeface="Microsoft Uighur"/>
+        <a:font script="Geor" typeface="Sylfaen"/>
+        <a:font script="Armn" typeface="Arial"/>
+        <a:font script="Bugi" typeface="Leelawadee UI"/>
+        <a:font script="Bopo" typeface="Microsoft JhengHei"/>
+        <a:font script="Java" typeface="Javanese Text"/>
+        <a:font script="Lisu" typeface="Segoe UI"/>
+        <a:font script="Mymr" typeface="Myanmar Text"/>
+        <a:font script="Nkoo" typeface="Ebrima"/>
+        <a:font script="Olck" typeface="Nirmala UI"/>
+        <a:font script="Osma" typeface="Ebrima"/>
+        <a:font script="Phag" typeface="Phagspa"/>
+        <a:font script="Syrn" typeface="Estrangelo Edessa"/>
+        <a:font script="Syrj" typeface="Estrangelo Edessa"/>
+        <a:font script="Syre" typeface="Estrangelo Edessa"/>
+        <a:font script="Sora" typeface="Nirmala UI"/>
+        <a:font script="Tale" typeface="Microsoft Tai Le"/>
+        <a:font script="Talu" typeface="Microsoft New Tai Lue"/>
+        <a:font script="Tfng" typeface="Ebrima"/>
+      </a:majorFont>
+      <a:minorFont>
+        <a:latin typeface="Aptos" panose="02110004020202020204"/>
+        <a:ea typeface=""/>
+        <a:cs typeface=""/>
+        <a:font script="Jpan" typeface="游ゴシック"/>
+        <a:font script="Hang" typeface="맑은 고딕"/>
+        <a:font script="Hans" typeface="等线"/>
+        <a:font script="Hant" typeface="新細明體"/>
+        <a:font script="Arab" typeface="Arial"/>
+        <a:font script="Hebr" typeface="Arial"/>
+        <a:font script="Thai" typeface="Cordia New"/>
+        <a:font script="Ethi" typeface="Nyala"/>
+        <a:font script="Beng" typeface="Vrinda"/>
+        <a:font script="Gujr" typeface="Shruti"/>
+        <a:font script="Khmr" typeface="DaunPenh"/>
+        <a:font script="Knda" typeface="Tunga"/>
+        <a:font script="Guru" typeface="Raavi"/>
+        <a:font script="Cans" typeface="Euphemia"/>
+        <a:font script="Cher" typeface="Plantagenet Cherokee"/>
+        <a:font script="Yiii" typeface="Microsoft Yi Baiti"/>
+        <a:font script="Tibt" typeface="Microsoft Himalaya"/>
+        <a:font script="Thaa" typeface="MV Boli"/>
+        <a:font script="Deva" typeface="Mangal"/>
+        <a:font script="Telu" typeface="Gautami"/>
+        <a:font script="Taml" typeface="Latha"/>
+        <a:font script="Syrc" typeface="Estrangelo Edessa"/>
+        <a:font script="Orya" typeface="Kalinga"/>
+        <a:font script="Mlym" typeface="Kartika"/>
+        <a:font script="Laoo" typeface="DokChampa"/>
+        <a:font script="Sinh" typeface="Iskoola Pota"/>
+        <a:font script="Mong" typeface="Mongolian Baiti"/>
+        <a:font script="Viet" typeface="Arial"/>
+        <a:font script="Uigh" typeface="Microsoft Uighur"/>
+        <a:font script="Geor" typeface="Sylfaen"/>
+        <a:font script="Armn" typeface="Arial"/>
+        <a:font script="Bugi" typeface="Leelawadee UI"/>
+        <a:font script="Bopo" typeface="Microsoft JhengHei"/>
+        <a:font script="Java" typeface="Javanese Text"/>
+        <a:font script="Lisu" typeface="Segoe UI"/>
+        <a:font script="Mymr" typeface="Myanmar Text"/>
+        <a:font script="Nkoo" typeface="Ebrima"/>
+        <a:font script="Olck" typeface="Nirmala UI"/>
+        <a:font script="Osma" typeface="Ebrima"/>
+        <a:font script="Phag" typeface="Phagspa"/>
+        <a:font script="Syrn" typeface="Estrangelo Edessa"/>
+        <a:font script="Syrj" typeface="Estrangelo Edessa"/>
+        <a:font script="Syre" typeface="Estrangelo Edessa"/>
+        <a:font script="Sora" typeface="Nirmala UI"/>
+        <a:font script="Tale" typeface="Microsoft Tai Le"/>
+        <a:font script="Talu" typeface="Microsoft New Tai Lue"/>
+        <a:font script="Tfng" typeface="Ebrima"/>
+      </a:minorFont>
+    </a:fontScheme>
+    <a:fmtScheme name="Office">
+      <a:fillStyleLst>
+        <a:solidFill>
+          <a:schemeClr val="phClr"/>
+        </a:solidFill>
+        <a:gradFill rotWithShape="1">
+          <a:gsLst>
+            <a:gs pos="0">
+              <a:schemeClr val="phClr">
+                <a:lumMod val="110000"/>
+                <a:satMod val="105000"/>
+                <a:tint val="67000"/>
+              </a:schemeClr>
+            </a:gs>
+            <a:gs pos="50000">
+              <a:schemeClr val="phClr">
+                <a:lumMod val="105000"/>
+                <a:satMod val="103000"/>
+                <a:tint val="73000"/>
+              </a:schemeClr>
+            </a:gs>
+            <a:gs pos="100000">
+              <a:schemeClr val="phClr">
+                <a:lumMod val="105000"/>
+                <a:satMod val="109000"/>
+                <a:tint val="81000"/>
+              </a:schemeClr>
+            </a:gs>
+          </a:gsLst>
+          <a:lin ang="5400000" scaled="0"/>
+        </a:gradFill>
+        <a:gradFill rotWithShape="1">
+          <a:gsLst>
+            <a:gs pos="0">
+              <a:schemeClr val="phClr">
+                <a:satMod val="103000"/>
+                <a:lumMod val="102000"/>
+                <a:tint val="94000"/>
+              </a:schemeClr>
+            </a:gs>
+            <a:gs pos="50000">
+              <a:schemeClr val="phClr">
+                <a:satMod val="110000"/>
+                <a:lumMod val="100000"/>
+                <a:shade val="100000"/>
+              </a:schemeClr>
+            </a:gs>
+            <a:gs pos="100000">
+              <a:schemeClr val="phClr">
+                <a:lumMod val="99000"/>
+                <a:satMod val="120000"/>
+                <a:shade val="78000"/>
+              </a:schemeClr>
+            </a:gs>
+          </a:gsLst>
+          <a:lin ang="5400000" scaled="0"/>
+        </a:gradFill>
+      </a:fillStyleLst>
+      <a:lnStyleLst>
+        <a:ln w="12700" cap="flat" cmpd="sng" algn="ctr">
+          <a:solidFill>
+            <a:schemeClr val="phClr"/>
+          </a:solidFill>
+          <a:prstDash val="solid"/>
+          <a:miter lim="800000"/>
+        </a:ln>
+        <a:ln w="19050" cap="flat" cmpd="sng" algn="ctr">
+          <a:solidFill>
+            <a:schemeClr val="phClr"/>
+          </a:solidFill>
+          <a:prstDash val="solid"/>
+          <a:miter lim="800000"/>
+        </a:ln>
+        <a:ln w="25400" cap="flat" cmpd="sng" algn="ctr">
+          <a:solidFill>
+            <a:schemeClr val="phClr"/>
+          </a:solidFill>
+          <a:prstDash val="solid"/>
+          <a:miter lim="800000"/>
+        </a:ln>
+      </a:lnStyleLst>
+      <a:effectStyleLst>
+        <a:effectStyle>
+          <a:effectLst/>
+        </a:effectStyle>
+        <a:effectStyle>
+          <a:effectLst/>
+        </a:effectStyle>
+        <a:effectStyle>
+          <a:effectLst>
+            <a:outerShdw blurRad="57150" dist="19050" dir="5400000" algn="ctr" rotWithShape="0">
+              <a:srgbClr val="000000">
+                <a:alpha val="63000"/>
+              </a:srgbClr>
+            </a:outerShdw>
+          </a:effectLst>
+        </a:effectStyle>
+      </a:effectStyleLst>
+      <a:bgFillStyleLst>
+        <a:solidFill>
+          <a:schemeClr val="phClr"/>
+        </a:solidFill>
+        <a:solidFill>
+          <a:schemeClr val="phClr">
+            <a:tint val="95000"/>
+            <a:satMod val="170000"/>
+          </a:schemeClr>
+        </a:solidFill>
+        <a:gradFill rotWithShape="1">
+          <a:gsLst>
+            <a:gs pos="0">
+              <a:schemeClr val="phClr">
+                <a:tint val="93000"/>
+                <a:satMod val="150000"/>
+                <a:shade val="98000"/>
+                <a:lumMod val="102000"/>
+              </a:schemeClr>
+            </a:gs>
+            <a:gs pos="50000">
+              <a:schemeClr val="phClr">
+                <a:tint val="98000"/>
+                <a:satMod val="130000"/>
+                <a:shade val="90000"/>
+                <a:lumMod val="103000"/>
+              </a:schemeClr>
+            </a:gs>
+            <a:gs pos="100000">
+              <a:schemeClr val="phClr">
+                <a:shade val="63000"/>
+                <a:satMod val="120000"/>
+              </a:schemeClr>
+            </a:gs>
+          </a:gsLst>
+          <a:lin ang="5400000" scaled="0"/>
+        </a:gradFill>
+      </a:bgFillStyleLst>
+    </a:fmtScheme>
+  </a:themeElements>
+  <a:objectDefaults>
+    <a:lnDef>
+      <a:spPr/>
+      <a:bodyPr/>
+      <a:lstStyle/>
+      <a:style>
+        <a:lnRef idx="2">
+          <a:schemeClr val="accent1"/>
+        </a:lnRef>
+        <a:fillRef idx="0">
+          <a:schemeClr val="accent1"/>
+        </a:fillRef>
+        <a:effectRef idx="1">
+          <a:schemeClr val="accent1"/>
+        </a:effectRef>
+        <a:fontRef idx="minor">
+          <a:schemeClr val="tx1"/>
+        </a:fontRef>
+      </a:style>
+    </a:lnDef>
+  </a:objectDefaults>
+  <a:extraClrSchemeLst/>
+  <a:extLst>
+    <a:ext uri="{05A4C25C-085E-4340-85A3-A5531E510DB2}">
+      <thm15:themeFamily xmlns:thm15="http://schemas.microsoft.com/office/thememl/2012/main" name="Office Theme" id="{2E142A2C-CD16-42D6-873A-C26D2A0506FA}" vid="{1BDDFF52-6CD6-40A5-AB3C-68EB2F1E4D0A}"/>
+    </a:ext>
+  </a:extLst>
+</a:theme>
 </file>
</xml_diff>